<commit_message>
vault backup: 2026-08-22 23:37:39
</commit_message>
<xml_diff>
--- a/0-INBOX/presentation-humanities-2026/verification-deck.pptx
+++ b/0-INBOX/presentation-humanities-2026/verification-deck.pptx
@@ -3645,10 +3645,8 @@
             <a:off x="0" y="0"/>
             <a:ext cx="12191695" cy="6858000"/>
           </a:xfrm>
-          <a:prstGeom prst="roundRect">
-            <a:avLst>
-              <a:gd name="adj" fmla="val 800"/>
-            </a:avLst>
+          <a:prstGeom prst="rect">
+            <a:avLst/>
           </a:prstGeom>
           <a:solidFill>
             <a:srgbClr val="E5E0D8"/>
@@ -3663,63 +3661,7 @@
       </p:sp>
       <p:sp>
         <p:nvSpPr>
-          <p:cNvPr id="3" name="Text 1"/>
-          <p:cNvSpPr/>
-          <p:nvPr/>
-        </p:nvSpPr>
-        <p:spPr>
-          <a:xfrm>
-            <a:off x="0" y="0"/>
-            <a:ext cx="12191695" cy="6858000"/>
-          </a:xfrm>
-          <a:prstGeom prst="rect">
-            <a:avLst/>
-          </a:prstGeom>
-          <a:noFill/>
-          <a:ln/>
-        </p:spPr>
-        <p:txBody>
-          <a:bodyPr wrap="square" lIns="76200" tIns="76200" rIns="76200" bIns="76200" rtlCol="0" anchor="ctr"/>
-          <a:lstStyle/>
-          <a:p>
-            <a:pPr algn="ctr" indent="0" marL="0">
-              <a:buNone/>
-            </a:pPr>
-            <a:r>
-              <a:rPr lang="en-US" sz="1200" b="1" dirty="0">
-                <a:solidFill>
-                  <a:srgbClr val="8A8378"/>
-                </a:solidFill>
-                <a:latin typeface="JetBrains Mono" pitchFamily="34" charset="0"/>
-                <a:ea typeface="JetBrains Mono" pitchFamily="34" charset="-122"/>
-                <a:cs typeface="JetBrains Mono" pitchFamily="34" charset="-120"/>
-              </a:rPr>
-              <a:t>IMG-01</a:t>
-            </a:r>
-            <a:endParaRPr lang="en-US" sz="1200" dirty="0"/>
-          </a:p>
-          <a:p>
-            <a:pPr algn="ctr" indent="0" marL="0">
-              <a:buNone/>
-            </a:pPr>
-            <a:r>
-              <a:rPr lang="en-US" sz="1000" dirty="0">
-                <a:solidFill>
-                  <a:srgbClr val="8A8378"/>
-                </a:solidFill>
-                <a:latin typeface="JetBrains Mono" pitchFamily="34" charset="0"/>
-                <a:ea typeface="JetBrains Mono" pitchFamily="34" charset="-122"/>
-                <a:cs typeface="JetBrains Mono" pitchFamily="34" charset="-120"/>
-              </a:rPr>
-              <a:t>darkened photograph of a Tibetan pecha — full-bleed</a:t>
-            </a:r>
-            <a:endParaRPr lang="en-US" sz="1200" dirty="0"/>
-          </a:p>
-        </p:txBody>
-      </p:sp>
-      <p:sp>
-        <p:nvSpPr>
-          <p:cNvPr id="4" name="Shape 2"/>
+          <p:cNvPr id="3" name="Shape 1"/>
           <p:cNvSpPr/>
           <p:nvPr/>
         </p:nvSpPr>
@@ -3741,7 +3683,7 @@
       </p:sp>
       <p:sp>
         <p:nvSpPr>
-          <p:cNvPr id="5" name="Text 3"/>
+          <p:cNvPr id="4" name="Text 2"/>
           <p:cNvSpPr/>
           <p:nvPr/>
         </p:nvSpPr>
@@ -3780,7 +3722,7 @@
       </p:sp>
       <p:sp>
         <p:nvSpPr>
-          <p:cNvPr id="6" name="Text 4"/>
+          <p:cNvPr id="5" name="Text 3"/>
           <p:cNvSpPr/>
           <p:nvPr/>
         </p:nvSpPr>
@@ -3819,7 +3761,7 @@
       </p:sp>
       <p:sp>
         <p:nvSpPr>
-          <p:cNvPr id="7" name="Text 5"/>
+          <p:cNvPr id="6" name="Text 4"/>
           <p:cNvSpPr/>
           <p:nvPr/>
         </p:nvSpPr>
@@ -3858,7 +3800,7 @@
       </p:sp>
       <p:sp>
         <p:nvSpPr>
-          <p:cNvPr id="8" name="Text 6"/>
+          <p:cNvPr id="7" name="Text 5"/>
           <p:cNvSpPr/>
           <p:nvPr/>
         </p:nvSpPr>
@@ -7898,8 +7840,8 @@
           <p:nvPr/>
         </p:nvSpPr>
         <p:spPr>
-          <a:xfrm rot="-240000">
-            <a:off x="3200400" y="2286000"/>
+          <a:xfrm rot="-180000">
+            <a:off x="2331720" y="2286000"/>
             <a:ext cx="4206240" cy="2788920"/>
           </a:xfrm>
           <a:prstGeom prst="roundRect">
@@ -7926,7 +7868,7 @@
         </p:nvSpPr>
         <p:spPr>
           <a:xfrm rot="180000">
-            <a:off x="4663440" y="2212848"/>
+            <a:off x="6675120" y="2395728"/>
             <a:ext cx="4206240" cy="2788920"/>
           </a:xfrm>
           <a:prstGeom prst="roundRect">
@@ -7953,7 +7895,7 @@
         </p:nvSpPr>
         <p:spPr>
           <a:xfrm rot="-60000">
-            <a:off x="3931920" y="2377440"/>
+            <a:off x="4526280" y="2331720"/>
             <a:ext cx="4206240" cy="2788920"/>
           </a:xfrm>
           <a:prstGeom prst="roundRect">
@@ -9890,7 +9832,7 @@
         </p:nvSpPr>
         <p:spPr>
           <a:xfrm>
-            <a:off x="8138160" y="1691640"/>
+            <a:off x="8138160" y="1353312"/>
             <a:ext cx="3291840" cy="274320"/>
           </a:xfrm>
           <a:prstGeom prst="rect">
@@ -17843,13 +17785,33 @@
       </p:sp>
       <p:sp>
         <p:nvSpPr>
-          <p:cNvPr id="21" name="Text 19"/>
-          <p:cNvSpPr/>
-          <p:nvPr/>
-        </p:nvSpPr>
-        <p:spPr>
-          <a:xfrm>
-            <a:off x="11091672" y="5148072"/>
+          <p:cNvPr id="21" name="Shape 19"/>
+          <p:cNvSpPr/>
+          <p:nvPr/>
+        </p:nvSpPr>
+        <p:spPr>
+          <a:xfrm>
+            <a:off x="2788920" y="5513832"/>
+            <a:ext cx="18288" cy="274320"/>
+          </a:xfrm>
+          <a:prstGeom prst="rect">
+            <a:avLst/>
+          </a:prstGeom>
+          <a:solidFill>
+            <a:srgbClr val="B03A1E"/>
+          </a:solidFill>
+          <a:ln/>
+        </p:spPr>
+      </p:sp>
+      <p:sp>
+        <p:nvSpPr>
+          <p:cNvPr id="22" name="Text 20"/>
+          <p:cNvSpPr/>
+          <p:nvPr/>
+        </p:nvSpPr>
+        <p:spPr>
+          <a:xfrm>
+            <a:off x="2880360" y="5495544"/>
             <a:ext cx="2103120" cy="310896"/>
           </a:xfrm>
           <a:prstGeom prst="rect">
@@ -17866,15 +17828,15 @@
               <a:buNone/>
             </a:pPr>
             <a:r>
-              <a:rPr lang="en-US" sz="1050" dirty="0">
-                <a:solidFill>
-                  <a:srgbClr val="8A8378"/>
+              <a:rPr lang="en-US" sz="1050" b="1" dirty="0">
+                <a:solidFill>
+                  <a:srgbClr val="B03A1E"/>
                 </a:solidFill>
                 <a:latin typeface="JetBrains Mono" pitchFamily="34" charset="0"/>
                 <a:ea typeface="JetBrains Mono" pitchFamily="34" charset="-122"/>
                 <a:cs typeface="JetBrains Mono" pitchFamily="34" charset="-120"/>
               </a:rPr>
-              <a:t>7,000,000 speakers</a:t>
+              <a:t>8,073 articles</a:t>
             </a:r>
             <a:endParaRPr lang="en-US" sz="1050" dirty="0"/>
           </a:p>
@@ -17882,66 +17844,7 @@
       </p:sp>
       <p:sp>
         <p:nvSpPr>
-          <p:cNvPr id="22" name="Shape 20"/>
-          <p:cNvSpPr/>
-          <p:nvPr/>
-        </p:nvSpPr>
-        <p:spPr>
-          <a:xfrm>
-            <a:off x="2788920" y="5513832"/>
-            <a:ext cx="18288" cy="274320"/>
-          </a:xfrm>
-          <a:prstGeom prst="rect">
-            <a:avLst/>
-          </a:prstGeom>
-          <a:solidFill>
-            <a:srgbClr val="B03A1E"/>
-          </a:solidFill>
-          <a:ln/>
-        </p:spPr>
-      </p:sp>
-      <p:sp>
-        <p:nvSpPr>
           <p:cNvPr id="23" name="Text 21"/>
-          <p:cNvSpPr/>
-          <p:nvPr/>
-        </p:nvSpPr>
-        <p:spPr>
-          <a:xfrm>
-            <a:off x="2880360" y="5495544"/>
-            <a:ext cx="2103120" cy="310896"/>
-          </a:xfrm>
-          <a:prstGeom prst="rect">
-            <a:avLst/>
-          </a:prstGeom>
-          <a:noFill/>
-          <a:ln/>
-        </p:spPr>
-        <p:txBody>
-          <a:bodyPr wrap="square" lIns="0" tIns="0" rIns="0" bIns="0" rtlCol="0" anchor="ctr"/>
-          <a:lstStyle/>
-          <a:p>
-            <a:pPr indent="0" marL="0">
-              <a:buNone/>
-            </a:pPr>
-            <a:r>
-              <a:rPr lang="en-US" sz="1050" b="1" dirty="0">
-                <a:solidFill>
-                  <a:srgbClr val="B03A1E"/>
-                </a:solidFill>
-                <a:latin typeface="JetBrains Mono" pitchFamily="34" charset="0"/>
-                <a:ea typeface="JetBrains Mono" pitchFamily="34" charset="-122"/>
-                <a:cs typeface="JetBrains Mono" pitchFamily="34" charset="-120"/>
-              </a:rPr>
-              <a:t>8,073 articles</a:t>
-            </a:r>
-            <a:endParaRPr lang="en-US" sz="1050" dirty="0"/>
-          </a:p>
-        </p:txBody>
-      </p:sp>
-      <p:sp>
-        <p:nvSpPr>
-          <p:cNvPr id="24" name="Text 22"/>
           <p:cNvSpPr/>
           <p:nvPr/>
         </p:nvSpPr>
@@ -21243,8 +21146,8 @@
         </p:nvSpPr>
         <p:spPr>
           <a:xfrm>
-            <a:off x="960120" y="2011680"/>
-            <a:ext cx="365760" cy="3703320"/>
+            <a:off x="960120" y="1965960"/>
+            <a:ext cx="365760" cy="3840480"/>
           </a:xfrm>
           <a:prstGeom prst="rect">
             <a:avLst/>
@@ -21258,7 +21161,7 @@
           <a:p>
             <a:pPr algn="ctr" indent="0" marL="0">
               <a:lnSpc>
-                <a:spcPts val="1300"/>
+                <a:spcPts val="1800"/>
               </a:lnSpc>
               <a:buNone/>
             </a:pPr>
@@ -21278,7 +21181,7 @@
           <a:p>
             <a:pPr algn="ctr" indent="0" marL="0">
               <a:lnSpc>
-                <a:spcPts val="1300"/>
+                <a:spcPts val="1800"/>
               </a:lnSpc>
               <a:buNone/>
             </a:pPr>
@@ -21298,7 +21201,7 @@
           <a:p>
             <a:pPr algn="ctr" indent="0" marL="0">
               <a:lnSpc>
-                <a:spcPts val="1300"/>
+                <a:spcPts val="1800"/>
               </a:lnSpc>
               <a:buNone/>
             </a:pPr>
@@ -21318,7 +21221,7 @@
           <a:p>
             <a:pPr algn="ctr" indent="0" marL="0">
               <a:lnSpc>
-                <a:spcPts val="1300"/>
+                <a:spcPts val="1800"/>
               </a:lnSpc>
               <a:buNone/>
             </a:pPr>
@@ -21338,7 +21241,7 @@
           <a:p>
             <a:pPr algn="ctr" indent="0" marL="0">
               <a:lnSpc>
-                <a:spcPts val="1300"/>
+                <a:spcPts val="1800"/>
               </a:lnSpc>
               <a:buNone/>
             </a:pPr>
@@ -21358,7 +21261,7 @@
           <a:p>
             <a:pPr algn="ctr" indent="0" marL="0">
               <a:lnSpc>
-                <a:spcPts val="1300"/>
+                <a:spcPts val="1800"/>
               </a:lnSpc>
               <a:buNone/>
             </a:pPr>
@@ -21378,7 +21281,7 @@
           <a:p>
             <a:pPr algn="ctr" indent="0" marL="0">
               <a:lnSpc>
-                <a:spcPts val="1300"/>
+                <a:spcPts val="1800"/>
               </a:lnSpc>
               <a:buNone/>
             </a:pPr>
@@ -21398,7 +21301,7 @@
           <a:p>
             <a:pPr algn="ctr" indent="0" marL="0">
               <a:lnSpc>
-                <a:spcPts val="1300"/>
+                <a:spcPts val="1800"/>
               </a:lnSpc>
               <a:buNone/>
             </a:pPr>
@@ -21415,39 +21318,17 @@
             </a:r>
             <a:endParaRPr lang="en-US" sz="1000" dirty="0"/>
           </a:p>
-        </p:txBody>
-      </p:sp>
-      <p:sp>
-        <p:nvSpPr>
-          <p:cNvPr id="6" name="Text 4"/>
-          <p:cNvSpPr/>
-          <p:nvPr/>
-        </p:nvSpPr>
-        <p:spPr>
-          <a:xfrm>
-            <a:off x="1463040" y="2011680"/>
-            <a:ext cx="365760" cy="3703320"/>
-          </a:xfrm>
-          <a:prstGeom prst="rect">
-            <a:avLst/>
-          </a:prstGeom>
-          <a:noFill/>
-          <a:ln/>
-        </p:spPr>
-        <p:txBody>
-          <a:bodyPr wrap="square" lIns="0" tIns="0" rIns="0" bIns="0" rtlCol="0" anchor="t"/>
-          <a:lstStyle/>
           <a:p>
             <a:pPr algn="ctr" indent="0" marL="0">
               <a:lnSpc>
-                <a:spcPts val="1300"/>
+                <a:spcPts val="1800"/>
               </a:lnSpc>
               <a:buNone/>
             </a:pPr>
             <a:r>
               <a:rPr lang="en-US" sz="1000" dirty="0">
                 <a:solidFill>
-                  <a:srgbClr val="2ECC71"/>
+                  <a:srgbClr val="58D68D"/>
                 </a:solidFill>
                 <a:latin typeface="JetBrains Mono" pitchFamily="34" charset="0"/>
                 <a:ea typeface="JetBrains Mono" pitchFamily="34" charset="-122"/>
@@ -21460,14 +21341,14 @@
           <a:p>
             <a:pPr algn="ctr" indent="0" marL="0">
               <a:lnSpc>
-                <a:spcPts val="1300"/>
+                <a:spcPts val="1800"/>
               </a:lnSpc>
               <a:buNone/>
             </a:pPr>
             <a:r>
               <a:rPr lang="en-US" sz="1000" dirty="0">
                 <a:solidFill>
-                  <a:srgbClr val="2ECC71"/>
+                  <a:srgbClr val="58D68D"/>
                 </a:solidFill>
                 <a:latin typeface="JetBrains Mono" pitchFamily="34" charset="0"/>
                 <a:ea typeface="JetBrains Mono" pitchFamily="34" charset="-122"/>
@@ -21480,14 +21361,14 @@
           <a:p>
             <a:pPr algn="ctr" indent="0" marL="0">
               <a:lnSpc>
-                <a:spcPts val="1300"/>
+                <a:spcPts val="1800"/>
               </a:lnSpc>
               <a:buNone/>
             </a:pPr>
             <a:r>
               <a:rPr lang="en-US" sz="1000" dirty="0">
                 <a:solidFill>
-                  <a:srgbClr val="2ECC71"/>
+                  <a:srgbClr val="58D68D"/>
                 </a:solidFill>
                 <a:latin typeface="JetBrains Mono" pitchFamily="34" charset="0"/>
                 <a:ea typeface="JetBrains Mono" pitchFamily="34" charset="-122"/>
@@ -21500,14 +21381,14 @@
           <a:p>
             <a:pPr algn="ctr" indent="0" marL="0">
               <a:lnSpc>
-                <a:spcPts val="1300"/>
+                <a:spcPts val="1800"/>
               </a:lnSpc>
               <a:buNone/>
             </a:pPr>
             <a:r>
               <a:rPr lang="en-US" sz="1000" dirty="0">
                 <a:solidFill>
-                  <a:srgbClr val="2ECC71"/>
+                  <a:srgbClr val="58D68D"/>
                 </a:solidFill>
                 <a:latin typeface="JetBrains Mono" pitchFamily="34" charset="0"/>
                 <a:ea typeface="JetBrains Mono" pitchFamily="34" charset="-122"/>
@@ -21520,14 +21401,14 @@
           <a:p>
             <a:pPr algn="ctr" indent="0" marL="0">
               <a:lnSpc>
-                <a:spcPts val="1300"/>
+                <a:spcPts val="1800"/>
               </a:lnSpc>
               <a:buNone/>
             </a:pPr>
             <a:r>
               <a:rPr lang="en-US" sz="1000" dirty="0">
                 <a:solidFill>
-                  <a:srgbClr val="2ECC71"/>
+                  <a:srgbClr val="58D68D"/>
                 </a:solidFill>
                 <a:latin typeface="JetBrains Mono" pitchFamily="34" charset="0"/>
                 <a:ea typeface="JetBrains Mono" pitchFamily="34" charset="-122"/>
@@ -21540,14 +21421,14 @@
           <a:p>
             <a:pPr algn="ctr" indent="0" marL="0">
               <a:lnSpc>
-                <a:spcPts val="1300"/>
+                <a:spcPts val="1800"/>
               </a:lnSpc>
               <a:buNone/>
             </a:pPr>
             <a:r>
               <a:rPr lang="en-US" sz="1000" dirty="0">
                 <a:solidFill>
-                  <a:srgbClr val="2ECC71"/>
+                  <a:srgbClr val="58D68D"/>
                 </a:solidFill>
                 <a:latin typeface="JetBrains Mono" pitchFamily="34" charset="0"/>
                 <a:ea typeface="JetBrains Mono" pitchFamily="34" charset="-122"/>
@@ -21560,14 +21441,14 @@
           <a:p>
             <a:pPr algn="ctr" indent="0" marL="0">
               <a:lnSpc>
-                <a:spcPts val="1300"/>
+                <a:spcPts val="1800"/>
               </a:lnSpc>
               <a:buNone/>
             </a:pPr>
             <a:r>
               <a:rPr lang="en-US" sz="1000" dirty="0">
                 <a:solidFill>
-                  <a:srgbClr val="2ECC71"/>
+                  <a:srgbClr val="58D68D"/>
                 </a:solidFill>
                 <a:latin typeface="JetBrains Mono" pitchFamily="34" charset="0"/>
                 <a:ea typeface="JetBrains Mono" pitchFamily="34" charset="-122"/>
@@ -21580,14 +21461,14 @@
           <a:p>
             <a:pPr algn="ctr" indent="0" marL="0">
               <a:lnSpc>
-                <a:spcPts val="1300"/>
+                <a:spcPts val="1800"/>
               </a:lnSpc>
               <a:buNone/>
             </a:pPr>
             <a:r>
               <a:rPr lang="en-US" sz="1000" dirty="0">
                 <a:solidFill>
-                  <a:srgbClr val="2ECC71"/>
+                  <a:srgbClr val="58D68D"/>
                 </a:solidFill>
                 <a:latin typeface="JetBrains Mono" pitchFamily="34" charset="0"/>
                 <a:ea typeface="JetBrains Mono" pitchFamily="34" charset="-122"/>
@@ -21601,14 +21482,14 @@
       </p:sp>
       <p:sp>
         <p:nvSpPr>
-          <p:cNvPr id="7" name="Text 5"/>
-          <p:cNvSpPr/>
-          <p:nvPr/>
-        </p:nvSpPr>
-        <p:spPr>
-          <a:xfrm>
-            <a:off x="1965960" y="2011680"/>
-            <a:ext cx="365760" cy="3703320"/>
+          <p:cNvPr id="6" name="Text 4"/>
+          <p:cNvSpPr/>
+          <p:nvPr/>
+        </p:nvSpPr>
+        <p:spPr>
+          <a:xfrm>
+            <a:off x="1463040" y="1965960"/>
+            <a:ext cx="365760" cy="3840480"/>
           </a:xfrm>
           <a:prstGeom prst="rect">
             <a:avLst/>
@@ -21622,342 +21503,320 @@
           <a:p>
             <a:pPr algn="ctr" indent="0" marL="0">
               <a:lnSpc>
-                <a:spcPts val="1300"/>
+                <a:spcPts val="1800"/>
               </a:lnSpc>
               <a:buNone/>
             </a:pPr>
             <a:r>
               <a:rPr lang="en-US" sz="1000" dirty="0">
                 <a:solidFill>
-                  <a:srgbClr val="27AE60"/>
+                  <a:srgbClr val="2ECC71"/>
                 </a:solidFill>
                 <a:latin typeface="JetBrains Mono" pitchFamily="34" charset="0"/>
                 <a:ea typeface="JetBrains Mono" pitchFamily="34" charset="-122"/>
                 <a:cs typeface="JetBrains Mono" pitchFamily="34" charset="-120"/>
               </a:rPr>
-              <a:t>y</a:t>
+              <a:t>0</a:t>
             </a:r>
             <a:endParaRPr lang="en-US" sz="1000" dirty="0"/>
           </a:p>
           <a:p>
             <a:pPr algn="ctr" indent="0" marL="0">
               <a:lnSpc>
-                <a:spcPts val="1300"/>
+                <a:spcPts val="1800"/>
               </a:lnSpc>
               <a:buNone/>
             </a:pPr>
             <a:r>
               <a:rPr lang="en-US" sz="1000" dirty="0">
                 <a:solidFill>
-                  <a:srgbClr val="27AE60"/>
+                  <a:srgbClr val="2ECC71"/>
                 </a:solidFill>
                 <a:latin typeface="JetBrains Mono" pitchFamily="34" charset="0"/>
                 <a:ea typeface="JetBrains Mono" pitchFamily="34" charset="-122"/>
                 <a:cs typeface="JetBrains Mono" pitchFamily="34" charset="-120"/>
               </a:rPr>
-              <a:t>3</a:t>
+              <a:t>x</a:t>
             </a:r>
             <a:endParaRPr lang="en-US" sz="1000" dirty="0"/>
           </a:p>
           <a:p>
             <a:pPr algn="ctr" indent="0" marL="0">
               <a:lnSpc>
-                <a:spcPts val="1300"/>
+                <a:spcPts val="1800"/>
               </a:lnSpc>
               <a:buNone/>
             </a:pPr>
             <a:r>
               <a:rPr lang="en-US" sz="1000" dirty="0">
                 <a:solidFill>
-                  <a:srgbClr val="27AE60"/>
+                  <a:srgbClr val="2ECC71"/>
                 </a:solidFill>
                 <a:latin typeface="JetBrains Mono" pitchFamily="34" charset="0"/>
                 <a:ea typeface="JetBrains Mono" pitchFamily="34" charset="-122"/>
                 <a:cs typeface="JetBrains Mono" pitchFamily="34" charset="-120"/>
               </a:rPr>
-              <a:t>0</a:t>
+              <a:t>1</a:t>
             </a:r>
             <a:endParaRPr lang="en-US" sz="1000" dirty="0"/>
           </a:p>
           <a:p>
             <a:pPr algn="ctr" indent="0" marL="0">
               <a:lnSpc>
-                <a:spcPts val="1300"/>
+                <a:spcPts val="1800"/>
               </a:lnSpc>
               <a:buNone/>
             </a:pPr>
             <a:r>
               <a:rPr lang="en-US" sz="1000" dirty="0">
                 <a:solidFill>
-                  <a:srgbClr val="27AE60"/>
+                  <a:srgbClr val="2ECC71"/>
                 </a:solidFill>
                 <a:latin typeface="JetBrains Mono" pitchFamily="34" charset="0"/>
                 <a:ea typeface="JetBrains Mono" pitchFamily="34" charset="-122"/>
                 <a:cs typeface="JetBrains Mono" pitchFamily="34" charset="-120"/>
               </a:rPr>
-              <a:t>1</a:t>
+              <a:t>o</a:t>
             </a:r>
             <a:endParaRPr lang="en-US" sz="1000" dirty="0"/>
           </a:p>
           <a:p>
             <a:pPr algn="ctr" indent="0" marL="0">
               <a:lnSpc>
-                <a:spcPts val="1300"/>
+                <a:spcPts val="1800"/>
               </a:lnSpc>
               <a:buNone/>
             </a:pPr>
             <a:r>
               <a:rPr lang="en-US" sz="1000" dirty="0">
                 <a:solidFill>
-                  <a:srgbClr val="27AE60"/>
+                  <a:srgbClr val="2ECC71"/>
                 </a:solidFill>
                 <a:latin typeface="JetBrains Mono" pitchFamily="34" charset="0"/>
                 <a:ea typeface="JetBrains Mono" pitchFamily="34" charset="-122"/>
                 <a:cs typeface="JetBrains Mono" pitchFamily="34" charset="-120"/>
               </a:rPr>
-              <a:t>k</a:t>
+              <a:t>0</a:t>
             </a:r>
             <a:endParaRPr lang="en-US" sz="1000" dirty="0"/>
           </a:p>
           <a:p>
             <a:pPr algn="ctr" indent="0" marL="0">
               <a:lnSpc>
-                <a:spcPts val="1300"/>
+                <a:spcPts val="1800"/>
               </a:lnSpc>
               <a:buNone/>
             </a:pPr>
             <a:r>
               <a:rPr lang="en-US" sz="1000" dirty="0">
                 <a:solidFill>
-                  <a:srgbClr val="27AE60"/>
+                  <a:srgbClr val="2ECC71"/>
                 </a:solidFill>
                 <a:latin typeface="JetBrains Mono" pitchFamily="34" charset="0"/>
                 <a:ea typeface="JetBrains Mono" pitchFamily="34" charset="-122"/>
                 <a:cs typeface="JetBrains Mono" pitchFamily="34" charset="-120"/>
               </a:rPr>
-              <a:t>x</a:t>
+              <a:t>1</a:t>
             </a:r>
             <a:endParaRPr lang="en-US" sz="1000" dirty="0"/>
           </a:p>
           <a:p>
             <a:pPr algn="ctr" indent="0" marL="0">
               <a:lnSpc>
-                <a:spcPts val="1300"/>
+                <a:spcPts val="1800"/>
               </a:lnSpc>
               <a:buNone/>
             </a:pPr>
             <a:r>
               <a:rPr lang="en-US" sz="1000" dirty="0">
                 <a:solidFill>
-                  <a:srgbClr val="27AE60"/>
+                  <a:srgbClr val="2ECC71"/>
                 </a:solidFill>
                 <a:latin typeface="JetBrains Mono" pitchFamily="34" charset="0"/>
                 <a:ea typeface="JetBrains Mono" pitchFamily="34" charset="-122"/>
                 <a:cs typeface="JetBrains Mono" pitchFamily="34" charset="-120"/>
               </a:rPr>
-              <a:t>0</a:t>
+              <a:t>7</a:t>
             </a:r>
             <a:endParaRPr lang="en-US" sz="1000" dirty="0"/>
           </a:p>
           <a:p>
             <a:pPr algn="ctr" indent="0" marL="0">
               <a:lnSpc>
-                <a:spcPts val="1300"/>
+                <a:spcPts val="1800"/>
               </a:lnSpc>
               <a:buNone/>
             </a:pPr>
             <a:r>
               <a:rPr lang="en-US" sz="1000" dirty="0">
                 <a:solidFill>
-                  <a:srgbClr val="27AE60"/>
+                  <a:srgbClr val="2ECC71"/>
                 </a:solidFill>
                 <a:latin typeface="JetBrains Mono" pitchFamily="34" charset="0"/>
                 <a:ea typeface="JetBrains Mono" pitchFamily="34" charset="-122"/>
                 <a:cs typeface="JetBrains Mono" pitchFamily="34" charset="-120"/>
               </a:rPr>
-              <a:t>1</a:t>
+              <a:t>k</a:t>
             </a:r>
             <a:endParaRPr lang="en-US" sz="1000" dirty="0"/>
           </a:p>
-        </p:txBody>
-      </p:sp>
-      <p:sp>
-        <p:nvSpPr>
-          <p:cNvPr id="8" name="Text 6"/>
-          <p:cNvSpPr/>
-          <p:nvPr/>
-        </p:nvSpPr>
-        <p:spPr>
-          <a:xfrm>
-            <a:off x="2468880" y="2011680"/>
-            <a:ext cx="365760" cy="3703320"/>
-          </a:xfrm>
-          <a:prstGeom prst="rect">
-            <a:avLst/>
-          </a:prstGeom>
-          <a:noFill/>
-          <a:ln/>
-        </p:spPr>
-        <p:txBody>
-          <a:bodyPr wrap="square" lIns="0" tIns="0" rIns="0" bIns="0" rtlCol="0" anchor="t"/>
-          <a:lstStyle/>
           <a:p>
             <a:pPr algn="ctr" indent="0" marL="0">
               <a:lnSpc>
-                <a:spcPts val="1300"/>
+                <a:spcPts val="1800"/>
               </a:lnSpc>
               <a:buNone/>
             </a:pPr>
             <a:r>
               <a:rPr lang="en-US" sz="1000" dirty="0">
                 <a:solidFill>
-                  <a:srgbClr val="1E8449"/>
+                  <a:srgbClr val="2ECC71"/>
                 </a:solidFill>
                 <a:latin typeface="JetBrains Mono" pitchFamily="34" charset="0"/>
                 <a:ea typeface="JetBrains Mono" pitchFamily="34" charset="-122"/>
                 <a:cs typeface="JetBrains Mono" pitchFamily="34" charset="-120"/>
               </a:rPr>
-              <a:t>1</a:t>
+              <a:t>y</a:t>
             </a:r>
             <a:endParaRPr lang="en-US" sz="1000" dirty="0"/>
           </a:p>
           <a:p>
             <a:pPr algn="ctr" indent="0" marL="0">
               <a:lnSpc>
-                <a:spcPts val="1300"/>
+                <a:spcPts val="1800"/>
               </a:lnSpc>
               <a:buNone/>
             </a:pPr>
             <a:r>
               <a:rPr lang="en-US" sz="1000" dirty="0">
                 <a:solidFill>
-                  <a:srgbClr val="1E8449"/>
+                  <a:srgbClr val="2ECC71"/>
                 </a:solidFill>
                 <a:latin typeface="JetBrains Mono" pitchFamily="34" charset="0"/>
                 <a:ea typeface="JetBrains Mono" pitchFamily="34" charset="-122"/>
                 <a:cs typeface="JetBrains Mono" pitchFamily="34" charset="-120"/>
               </a:rPr>
-              <a:t>7</a:t>
+              <a:t>3</a:t>
             </a:r>
             <a:endParaRPr lang="en-US" sz="1000" dirty="0"/>
           </a:p>
           <a:p>
             <a:pPr algn="ctr" indent="0" marL="0">
               <a:lnSpc>
-                <a:spcPts val="1300"/>
+                <a:spcPts val="1800"/>
               </a:lnSpc>
               <a:buNone/>
             </a:pPr>
             <a:r>
               <a:rPr lang="en-US" sz="1000" dirty="0">
                 <a:solidFill>
-                  <a:srgbClr val="1E8449"/>
+                  <a:srgbClr val="2ECC71"/>
                 </a:solidFill>
                 <a:latin typeface="JetBrains Mono" pitchFamily="34" charset="0"/>
                 <a:ea typeface="JetBrains Mono" pitchFamily="34" charset="-122"/>
                 <a:cs typeface="JetBrains Mono" pitchFamily="34" charset="-120"/>
               </a:rPr>
-              <a:t>o</a:t>
+              <a:t>0</a:t>
             </a:r>
             <a:endParaRPr lang="en-US" sz="1000" dirty="0"/>
           </a:p>
           <a:p>
             <a:pPr algn="ctr" indent="0" marL="0">
               <a:lnSpc>
-                <a:spcPts val="1300"/>
+                <a:spcPts val="1800"/>
               </a:lnSpc>
               <a:buNone/>
             </a:pPr>
             <a:r>
               <a:rPr lang="en-US" sz="1000" dirty="0">
                 <a:solidFill>
-                  <a:srgbClr val="1E8449"/>
+                  <a:srgbClr val="2ECC71"/>
                 </a:solidFill>
                 <a:latin typeface="JetBrains Mono" pitchFamily="34" charset="0"/>
                 <a:ea typeface="JetBrains Mono" pitchFamily="34" charset="-122"/>
                 <a:cs typeface="JetBrains Mono" pitchFamily="34" charset="-120"/>
               </a:rPr>
-              <a:t>0</a:t>
+              <a:t>1</a:t>
             </a:r>
             <a:endParaRPr lang="en-US" sz="1000" dirty="0"/>
           </a:p>
           <a:p>
             <a:pPr algn="ctr" indent="0" marL="0">
               <a:lnSpc>
-                <a:spcPts val="1300"/>
+                <a:spcPts val="1800"/>
               </a:lnSpc>
               <a:buNone/>
             </a:pPr>
             <a:r>
               <a:rPr lang="en-US" sz="1000" dirty="0">
                 <a:solidFill>
-                  <a:srgbClr val="1E8449"/>
+                  <a:srgbClr val="2ECC71"/>
                 </a:solidFill>
                 <a:latin typeface="JetBrains Mono" pitchFamily="34" charset="0"/>
                 <a:ea typeface="JetBrains Mono" pitchFamily="34" charset="-122"/>
                 <a:cs typeface="JetBrains Mono" pitchFamily="34" charset="-120"/>
               </a:rPr>
-              <a:t>1</a:t>
+              <a:t>k</a:t>
             </a:r>
             <a:endParaRPr lang="en-US" sz="1000" dirty="0"/>
           </a:p>
           <a:p>
             <a:pPr algn="ctr" indent="0" marL="0">
               <a:lnSpc>
-                <a:spcPts val="1300"/>
+                <a:spcPts val="1800"/>
               </a:lnSpc>
               <a:buNone/>
             </a:pPr>
             <a:r>
               <a:rPr lang="en-US" sz="1000" dirty="0">
                 <a:solidFill>
-                  <a:srgbClr val="1E8449"/>
+                  <a:srgbClr val="2ECC71"/>
                 </a:solidFill>
                 <a:latin typeface="JetBrains Mono" pitchFamily="34" charset="0"/>
                 <a:ea typeface="JetBrains Mono" pitchFamily="34" charset="-122"/>
                 <a:cs typeface="JetBrains Mono" pitchFamily="34" charset="-120"/>
               </a:rPr>
-              <a:t>3</a:t>
+              <a:t>x</a:t>
             </a:r>
             <a:endParaRPr lang="en-US" sz="1000" dirty="0"/>
           </a:p>
           <a:p>
             <a:pPr algn="ctr" indent="0" marL="0">
               <a:lnSpc>
-                <a:spcPts val="1300"/>
+                <a:spcPts val="1800"/>
               </a:lnSpc>
               <a:buNone/>
             </a:pPr>
             <a:r>
               <a:rPr lang="en-US" sz="1000" dirty="0">
                 <a:solidFill>
-                  <a:srgbClr val="1E8449"/>
+                  <a:srgbClr val="2ECC71"/>
                 </a:solidFill>
                 <a:latin typeface="JetBrains Mono" pitchFamily="34" charset="0"/>
                 <a:ea typeface="JetBrains Mono" pitchFamily="34" charset="-122"/>
                 <a:cs typeface="JetBrains Mono" pitchFamily="34" charset="-120"/>
               </a:rPr>
-              <a:t>y</a:t>
+              <a:t>0</a:t>
             </a:r>
             <a:endParaRPr lang="en-US" sz="1000" dirty="0"/>
           </a:p>
           <a:p>
             <a:pPr algn="ctr" indent="0" marL="0">
               <a:lnSpc>
-                <a:spcPts val="1300"/>
+                <a:spcPts val="1800"/>
               </a:lnSpc>
               <a:buNone/>
             </a:pPr>
             <a:r>
               <a:rPr lang="en-US" sz="1000" dirty="0">
                 <a:solidFill>
-                  <a:srgbClr val="1E8449"/>
+                  <a:srgbClr val="2ECC71"/>
                 </a:solidFill>
                 <a:latin typeface="JetBrains Mono" pitchFamily="34" charset="0"/>
                 <a:ea typeface="JetBrains Mono" pitchFamily="34" charset="-122"/>
                 <a:cs typeface="JetBrains Mono" pitchFamily="34" charset="-120"/>
               </a:rPr>
-              <a:t>0</a:t>
+              <a:t>1</a:t>
             </a:r>
             <a:endParaRPr lang="en-US" sz="1000" dirty="0"/>
           </a:p>
@@ -21965,14 +21824,14 @@
       </p:sp>
       <p:sp>
         <p:nvSpPr>
-          <p:cNvPr id="9" name="Text 7"/>
-          <p:cNvSpPr/>
-          <p:nvPr/>
-        </p:nvSpPr>
-        <p:spPr>
-          <a:xfrm>
-            <a:off x="2971800" y="2011680"/>
-            <a:ext cx="365760" cy="3703320"/>
+          <p:cNvPr id="7" name="Text 5"/>
+          <p:cNvSpPr/>
+          <p:nvPr/>
+        </p:nvSpPr>
+        <p:spPr>
+          <a:xfrm>
+            <a:off x="1965960" y="1965960"/>
+            <a:ext cx="365760" cy="3840480"/>
           </a:xfrm>
           <a:prstGeom prst="rect">
             <a:avLst/>
@@ -21986,160 +21845,1004 @@
           <a:p>
             <a:pPr algn="ctr" indent="0" marL="0">
               <a:lnSpc>
-                <a:spcPts val="1300"/>
+                <a:spcPts val="1800"/>
               </a:lnSpc>
               <a:buNone/>
             </a:pPr>
             <a:r>
               <a:rPr lang="en-US" sz="1000" dirty="0">
                 <a:solidFill>
-                  <a:srgbClr val="145A32"/>
+                  <a:srgbClr val="27AE60"/>
                 </a:solidFill>
                 <a:latin typeface="JetBrains Mono" pitchFamily="34" charset="0"/>
                 <a:ea typeface="JetBrains Mono" pitchFamily="34" charset="-122"/>
                 <a:cs typeface="JetBrains Mono" pitchFamily="34" charset="-120"/>
               </a:rPr>
-              <a:t>0</a:t>
+              <a:t>y</a:t>
             </a:r>
             <a:endParaRPr lang="en-US" sz="1000" dirty="0"/>
           </a:p>
           <a:p>
             <a:pPr algn="ctr" indent="0" marL="0">
               <a:lnSpc>
-                <a:spcPts val="1300"/>
+                <a:spcPts val="1800"/>
               </a:lnSpc>
               <a:buNone/>
             </a:pPr>
             <a:r>
               <a:rPr lang="en-US" sz="1000" dirty="0">
                 <a:solidFill>
-                  <a:srgbClr val="145A32"/>
+                  <a:srgbClr val="27AE60"/>
                 </a:solidFill>
                 <a:latin typeface="JetBrains Mono" pitchFamily="34" charset="0"/>
                 <a:ea typeface="JetBrains Mono" pitchFamily="34" charset="-122"/>
                 <a:cs typeface="JetBrains Mono" pitchFamily="34" charset="-120"/>
               </a:rPr>
-              <a:t>1</a:t>
+              <a:t>3</a:t>
             </a:r>
             <a:endParaRPr lang="en-US" sz="1000" dirty="0"/>
           </a:p>
           <a:p>
             <a:pPr algn="ctr" indent="0" marL="0">
               <a:lnSpc>
-                <a:spcPts val="1300"/>
+                <a:spcPts val="1800"/>
               </a:lnSpc>
               <a:buNone/>
             </a:pPr>
             <a:r>
               <a:rPr lang="en-US" sz="1000" dirty="0">
                 <a:solidFill>
-                  <a:srgbClr val="145A32"/>
+                  <a:srgbClr val="27AE60"/>
                 </a:solidFill>
                 <a:latin typeface="JetBrains Mono" pitchFamily="34" charset="0"/>
                 <a:ea typeface="JetBrains Mono" pitchFamily="34" charset="-122"/>
                 <a:cs typeface="JetBrains Mono" pitchFamily="34" charset="-120"/>
               </a:rPr>
-              <a:t>x</a:t>
+              <a:t>0</a:t>
             </a:r>
             <a:endParaRPr lang="en-US" sz="1000" dirty="0"/>
           </a:p>
           <a:p>
             <a:pPr algn="ctr" indent="0" marL="0">
               <a:lnSpc>
-                <a:spcPts val="1300"/>
+                <a:spcPts val="1800"/>
               </a:lnSpc>
               <a:buNone/>
             </a:pPr>
             <a:r>
               <a:rPr lang="en-US" sz="1000" dirty="0">
                 <a:solidFill>
-                  <a:srgbClr val="145A32"/>
+                  <a:srgbClr val="27AE60"/>
                 </a:solidFill>
                 <a:latin typeface="JetBrains Mono" pitchFamily="34" charset="0"/>
                 <a:ea typeface="JetBrains Mono" pitchFamily="34" charset="-122"/>
                 <a:cs typeface="JetBrains Mono" pitchFamily="34" charset="-120"/>
               </a:rPr>
-              <a:t>k</a:t>
+              <a:t>1</a:t>
             </a:r>
             <a:endParaRPr lang="en-US" sz="1000" dirty="0"/>
           </a:p>
           <a:p>
             <a:pPr algn="ctr" indent="0" marL="0">
               <a:lnSpc>
-                <a:spcPts val="1300"/>
+                <a:spcPts val="1800"/>
               </a:lnSpc>
               <a:buNone/>
             </a:pPr>
             <a:r>
               <a:rPr lang="en-US" sz="1000" dirty="0">
                 <a:solidFill>
-                  <a:srgbClr val="145A32"/>
+                  <a:srgbClr val="27AE60"/>
                 </a:solidFill>
                 <a:latin typeface="JetBrains Mono" pitchFamily="34" charset="0"/>
                 <a:ea typeface="JetBrains Mono" pitchFamily="34" charset="-122"/>
                 <a:cs typeface="JetBrains Mono" pitchFamily="34" charset="-120"/>
               </a:rPr>
-              <a:t>7</a:t>
+              <a:t>k</a:t>
             </a:r>
             <a:endParaRPr lang="en-US" sz="1000" dirty="0"/>
           </a:p>
           <a:p>
             <a:pPr algn="ctr" indent="0" marL="0">
               <a:lnSpc>
-                <a:spcPts val="1300"/>
+                <a:spcPts val="1800"/>
               </a:lnSpc>
               <a:buNone/>
             </a:pPr>
             <a:r>
               <a:rPr lang="en-US" sz="1000" dirty="0">
                 <a:solidFill>
-                  <a:srgbClr val="145A32"/>
+                  <a:srgbClr val="27AE60"/>
                 </a:solidFill>
                 <a:latin typeface="JetBrains Mono" pitchFamily="34" charset="0"/>
                 <a:ea typeface="JetBrains Mono" pitchFamily="34" charset="-122"/>
                 <a:cs typeface="JetBrains Mono" pitchFamily="34" charset="-120"/>
               </a:rPr>
-              <a:t>0</a:t>
+              <a:t>x</a:t>
             </a:r>
             <a:endParaRPr lang="en-US" sz="1000" dirty="0"/>
           </a:p>
           <a:p>
             <a:pPr algn="ctr" indent="0" marL="0">
               <a:lnSpc>
-                <a:spcPts val="1300"/>
+                <a:spcPts val="1800"/>
               </a:lnSpc>
               <a:buNone/>
             </a:pPr>
             <a:r>
               <a:rPr lang="en-US" sz="1000" dirty="0">
                 <a:solidFill>
-                  <a:srgbClr val="145A32"/>
+                  <a:srgbClr val="27AE60"/>
                 </a:solidFill>
                 <a:latin typeface="JetBrains Mono" pitchFamily="34" charset="0"/>
                 <a:ea typeface="JetBrains Mono" pitchFamily="34" charset="-122"/>
                 <a:cs typeface="JetBrains Mono" pitchFamily="34" charset="-120"/>
               </a:rPr>
-              <a:t>1</a:t>
+              <a:t>0</a:t>
             </a:r>
             <a:endParaRPr lang="en-US" sz="1000" dirty="0"/>
           </a:p>
           <a:p>
             <a:pPr algn="ctr" indent="0" marL="0">
               <a:lnSpc>
-                <a:spcPts val="1300"/>
+                <a:spcPts val="1800"/>
               </a:lnSpc>
               <a:buNone/>
             </a:pPr>
             <a:r>
               <a:rPr lang="en-US" sz="1000" dirty="0">
                 <a:solidFill>
-                  <a:srgbClr val="145A32"/>
+                  <a:srgbClr val="27AE60"/>
                 </a:solidFill>
                 <a:latin typeface="JetBrains Mono" pitchFamily="34" charset="0"/>
                 <a:ea typeface="JetBrains Mono" pitchFamily="34" charset="-122"/>
                 <a:cs typeface="JetBrains Mono" pitchFamily="34" charset="-120"/>
               </a:rPr>
+              <a:t>1</a:t>
+            </a:r>
+            <a:endParaRPr lang="en-US" sz="1000" dirty="0"/>
+          </a:p>
+          <a:p>
+            <a:pPr algn="ctr" indent="0" marL="0">
+              <a:lnSpc>
+                <a:spcPts val="1800"/>
+              </a:lnSpc>
+              <a:buNone/>
+            </a:pPr>
+            <a:r>
+              <a:rPr lang="en-US" sz="1000" dirty="0">
+                <a:solidFill>
+                  <a:srgbClr val="27AE60"/>
+                </a:solidFill>
+                <a:latin typeface="JetBrains Mono" pitchFamily="34" charset="0"/>
+                <a:ea typeface="JetBrains Mono" pitchFamily="34" charset="-122"/>
+                <a:cs typeface="JetBrains Mono" pitchFamily="34" charset="-120"/>
+              </a:rPr>
+              <a:t>1</a:t>
+            </a:r>
+            <a:endParaRPr lang="en-US" sz="1000" dirty="0"/>
+          </a:p>
+          <a:p>
+            <a:pPr algn="ctr" indent="0" marL="0">
+              <a:lnSpc>
+                <a:spcPts val="1800"/>
+              </a:lnSpc>
+              <a:buNone/>
+            </a:pPr>
+            <a:r>
+              <a:rPr lang="en-US" sz="1000" dirty="0">
+                <a:solidFill>
+                  <a:srgbClr val="27AE60"/>
+                </a:solidFill>
+                <a:latin typeface="JetBrains Mono" pitchFamily="34" charset="0"/>
+                <a:ea typeface="JetBrains Mono" pitchFamily="34" charset="-122"/>
+                <a:cs typeface="JetBrains Mono" pitchFamily="34" charset="-120"/>
+              </a:rPr>
+              <a:t>7</a:t>
+            </a:r>
+            <a:endParaRPr lang="en-US" sz="1000" dirty="0"/>
+          </a:p>
+          <a:p>
+            <a:pPr algn="ctr" indent="0" marL="0">
+              <a:lnSpc>
+                <a:spcPts val="1800"/>
+              </a:lnSpc>
+              <a:buNone/>
+            </a:pPr>
+            <a:r>
+              <a:rPr lang="en-US" sz="1000" dirty="0">
+                <a:solidFill>
+                  <a:srgbClr val="27AE60"/>
+                </a:solidFill>
+                <a:latin typeface="JetBrains Mono" pitchFamily="34" charset="0"/>
+                <a:ea typeface="JetBrains Mono" pitchFamily="34" charset="-122"/>
+                <a:cs typeface="JetBrains Mono" pitchFamily="34" charset="-120"/>
+              </a:rPr>
+              <a:t>o</a:t>
+            </a:r>
+            <a:endParaRPr lang="en-US" sz="1000" dirty="0"/>
+          </a:p>
+          <a:p>
+            <a:pPr algn="ctr" indent="0" marL="0">
+              <a:lnSpc>
+                <a:spcPts val="1800"/>
+              </a:lnSpc>
+              <a:buNone/>
+            </a:pPr>
+            <a:r>
+              <a:rPr lang="en-US" sz="1000" dirty="0">
+                <a:solidFill>
+                  <a:srgbClr val="27AE60"/>
+                </a:solidFill>
+                <a:latin typeface="JetBrains Mono" pitchFamily="34" charset="0"/>
+                <a:ea typeface="JetBrains Mono" pitchFamily="34" charset="-122"/>
+                <a:cs typeface="JetBrains Mono" pitchFamily="34" charset="-120"/>
+              </a:rPr>
+              <a:t>0</a:t>
+            </a:r>
+            <a:endParaRPr lang="en-US" sz="1000" dirty="0"/>
+          </a:p>
+          <a:p>
+            <a:pPr algn="ctr" indent="0" marL="0">
+              <a:lnSpc>
+                <a:spcPts val="1800"/>
+              </a:lnSpc>
+              <a:buNone/>
+            </a:pPr>
+            <a:r>
+              <a:rPr lang="en-US" sz="1000" dirty="0">
+                <a:solidFill>
+                  <a:srgbClr val="27AE60"/>
+                </a:solidFill>
+                <a:latin typeface="JetBrains Mono" pitchFamily="34" charset="0"/>
+                <a:ea typeface="JetBrains Mono" pitchFamily="34" charset="-122"/>
+                <a:cs typeface="JetBrains Mono" pitchFamily="34" charset="-120"/>
+              </a:rPr>
+              <a:t>1</a:t>
+            </a:r>
+            <a:endParaRPr lang="en-US" sz="1000" dirty="0"/>
+          </a:p>
+          <a:p>
+            <a:pPr algn="ctr" indent="0" marL="0">
+              <a:lnSpc>
+                <a:spcPts val="1800"/>
+              </a:lnSpc>
+              <a:buNone/>
+            </a:pPr>
+            <a:r>
+              <a:rPr lang="en-US" sz="1000" dirty="0">
+                <a:solidFill>
+                  <a:srgbClr val="27AE60"/>
+                </a:solidFill>
+                <a:latin typeface="JetBrains Mono" pitchFamily="34" charset="0"/>
+                <a:ea typeface="JetBrains Mono" pitchFamily="34" charset="-122"/>
+                <a:cs typeface="JetBrains Mono" pitchFamily="34" charset="-120"/>
+              </a:rPr>
               <a:t>3</a:t>
+            </a:r>
+            <a:endParaRPr lang="en-US" sz="1000" dirty="0"/>
+          </a:p>
+          <a:p>
+            <a:pPr algn="ctr" indent="0" marL="0">
+              <a:lnSpc>
+                <a:spcPts val="1800"/>
+              </a:lnSpc>
+              <a:buNone/>
+            </a:pPr>
+            <a:r>
+              <a:rPr lang="en-US" sz="1000" dirty="0">
+                <a:solidFill>
+                  <a:srgbClr val="27AE60"/>
+                </a:solidFill>
+                <a:latin typeface="JetBrains Mono" pitchFamily="34" charset="0"/>
+                <a:ea typeface="JetBrains Mono" pitchFamily="34" charset="-122"/>
+                <a:cs typeface="JetBrains Mono" pitchFamily="34" charset="-120"/>
+              </a:rPr>
+              <a:t>y</a:t>
+            </a:r>
+            <a:endParaRPr lang="en-US" sz="1000" dirty="0"/>
+          </a:p>
+          <a:p>
+            <a:pPr algn="ctr" indent="0" marL="0">
+              <a:lnSpc>
+                <a:spcPts val="1800"/>
+              </a:lnSpc>
+              <a:buNone/>
+            </a:pPr>
+            <a:r>
+              <a:rPr lang="en-US" sz="1000" dirty="0">
+                <a:solidFill>
+                  <a:srgbClr val="27AE60"/>
+                </a:solidFill>
+                <a:latin typeface="JetBrains Mono" pitchFamily="34" charset="0"/>
+                <a:ea typeface="JetBrains Mono" pitchFamily="34" charset="-122"/>
+                <a:cs typeface="JetBrains Mono" pitchFamily="34" charset="-120"/>
+              </a:rPr>
+              <a:t>0</a:t>
+            </a:r>
+            <a:endParaRPr lang="en-US" sz="1000" dirty="0"/>
+          </a:p>
+        </p:txBody>
+      </p:sp>
+      <p:sp>
+        <p:nvSpPr>
+          <p:cNvPr id="8" name="Text 6"/>
+          <p:cNvSpPr/>
+          <p:nvPr/>
+        </p:nvSpPr>
+        <p:spPr>
+          <a:xfrm>
+            <a:off x="2468880" y="1965960"/>
+            <a:ext cx="365760" cy="3840480"/>
+          </a:xfrm>
+          <a:prstGeom prst="rect">
+            <a:avLst/>
+          </a:prstGeom>
+          <a:noFill/>
+          <a:ln/>
+        </p:spPr>
+        <p:txBody>
+          <a:bodyPr wrap="square" lIns="0" tIns="0" rIns="0" bIns="0" rtlCol="0" anchor="t"/>
+          <a:lstStyle/>
+          <a:p>
+            <a:pPr algn="ctr" indent="0" marL="0">
+              <a:lnSpc>
+                <a:spcPts val="1800"/>
+              </a:lnSpc>
+              <a:buNone/>
+            </a:pPr>
+            <a:r>
+              <a:rPr lang="en-US" sz="1000" dirty="0">
+                <a:solidFill>
+                  <a:srgbClr val="1E8449"/>
+                </a:solidFill>
+                <a:latin typeface="JetBrains Mono" pitchFamily="34" charset="0"/>
+                <a:ea typeface="JetBrains Mono" pitchFamily="34" charset="-122"/>
+                <a:cs typeface="JetBrains Mono" pitchFamily="34" charset="-120"/>
+              </a:rPr>
+              <a:t>1</a:t>
+            </a:r>
+            <a:endParaRPr lang="en-US" sz="1000" dirty="0"/>
+          </a:p>
+          <a:p>
+            <a:pPr algn="ctr" indent="0" marL="0">
+              <a:lnSpc>
+                <a:spcPts val="1800"/>
+              </a:lnSpc>
+              <a:buNone/>
+            </a:pPr>
+            <a:r>
+              <a:rPr lang="en-US" sz="1000" dirty="0">
+                <a:solidFill>
+                  <a:srgbClr val="1E8449"/>
+                </a:solidFill>
+                <a:latin typeface="JetBrains Mono" pitchFamily="34" charset="0"/>
+                <a:ea typeface="JetBrains Mono" pitchFamily="34" charset="-122"/>
+                <a:cs typeface="JetBrains Mono" pitchFamily="34" charset="-120"/>
+              </a:rPr>
+              <a:t>7</a:t>
+            </a:r>
+            <a:endParaRPr lang="en-US" sz="1000" dirty="0"/>
+          </a:p>
+          <a:p>
+            <a:pPr algn="ctr" indent="0" marL="0">
+              <a:lnSpc>
+                <a:spcPts val="1800"/>
+              </a:lnSpc>
+              <a:buNone/>
+            </a:pPr>
+            <a:r>
+              <a:rPr lang="en-US" sz="1000" dirty="0">
+                <a:solidFill>
+                  <a:srgbClr val="1E8449"/>
+                </a:solidFill>
+                <a:latin typeface="JetBrains Mono" pitchFamily="34" charset="0"/>
+                <a:ea typeface="JetBrains Mono" pitchFamily="34" charset="-122"/>
+                <a:cs typeface="JetBrains Mono" pitchFamily="34" charset="-120"/>
+              </a:rPr>
+              <a:t>o</a:t>
+            </a:r>
+            <a:endParaRPr lang="en-US" sz="1000" dirty="0"/>
+          </a:p>
+          <a:p>
+            <a:pPr algn="ctr" indent="0" marL="0">
+              <a:lnSpc>
+                <a:spcPts val="1800"/>
+              </a:lnSpc>
+              <a:buNone/>
+            </a:pPr>
+            <a:r>
+              <a:rPr lang="en-US" sz="1000" dirty="0">
+                <a:solidFill>
+                  <a:srgbClr val="1E8449"/>
+                </a:solidFill>
+                <a:latin typeface="JetBrains Mono" pitchFamily="34" charset="0"/>
+                <a:ea typeface="JetBrains Mono" pitchFamily="34" charset="-122"/>
+                <a:cs typeface="JetBrains Mono" pitchFamily="34" charset="-120"/>
+              </a:rPr>
+              <a:t>0</a:t>
+            </a:r>
+            <a:endParaRPr lang="en-US" sz="1000" dirty="0"/>
+          </a:p>
+          <a:p>
+            <a:pPr algn="ctr" indent="0" marL="0">
+              <a:lnSpc>
+                <a:spcPts val="1800"/>
+              </a:lnSpc>
+              <a:buNone/>
+            </a:pPr>
+            <a:r>
+              <a:rPr lang="en-US" sz="1000" dirty="0">
+                <a:solidFill>
+                  <a:srgbClr val="1E8449"/>
+                </a:solidFill>
+                <a:latin typeface="JetBrains Mono" pitchFamily="34" charset="0"/>
+                <a:ea typeface="JetBrains Mono" pitchFamily="34" charset="-122"/>
+                <a:cs typeface="JetBrains Mono" pitchFamily="34" charset="-120"/>
+              </a:rPr>
+              <a:t>1</a:t>
+            </a:r>
+            <a:endParaRPr lang="en-US" sz="1000" dirty="0"/>
+          </a:p>
+          <a:p>
+            <a:pPr algn="ctr" indent="0" marL="0">
+              <a:lnSpc>
+                <a:spcPts val="1800"/>
+              </a:lnSpc>
+              <a:buNone/>
+            </a:pPr>
+            <a:r>
+              <a:rPr lang="en-US" sz="1000" dirty="0">
+                <a:solidFill>
+                  <a:srgbClr val="1E8449"/>
+                </a:solidFill>
+                <a:latin typeface="JetBrains Mono" pitchFamily="34" charset="0"/>
+                <a:ea typeface="JetBrains Mono" pitchFamily="34" charset="-122"/>
+                <a:cs typeface="JetBrains Mono" pitchFamily="34" charset="-120"/>
+              </a:rPr>
+              <a:t>3</a:t>
+            </a:r>
+            <a:endParaRPr lang="en-US" sz="1000" dirty="0"/>
+          </a:p>
+          <a:p>
+            <a:pPr algn="ctr" indent="0" marL="0">
+              <a:lnSpc>
+                <a:spcPts val="1800"/>
+              </a:lnSpc>
+              <a:buNone/>
+            </a:pPr>
+            <a:r>
+              <a:rPr lang="en-US" sz="1000" dirty="0">
+                <a:solidFill>
+                  <a:srgbClr val="1E8449"/>
+                </a:solidFill>
+                <a:latin typeface="JetBrains Mono" pitchFamily="34" charset="0"/>
+                <a:ea typeface="JetBrains Mono" pitchFamily="34" charset="-122"/>
+                <a:cs typeface="JetBrains Mono" pitchFamily="34" charset="-120"/>
+              </a:rPr>
+              <a:t>y</a:t>
+            </a:r>
+            <a:endParaRPr lang="en-US" sz="1000" dirty="0"/>
+          </a:p>
+          <a:p>
+            <a:pPr algn="ctr" indent="0" marL="0">
+              <a:lnSpc>
+                <a:spcPts val="1800"/>
+              </a:lnSpc>
+              <a:buNone/>
+            </a:pPr>
+            <a:r>
+              <a:rPr lang="en-US" sz="1000" dirty="0">
+                <a:solidFill>
+                  <a:srgbClr val="1E8449"/>
+                </a:solidFill>
+                <a:latin typeface="JetBrains Mono" pitchFamily="34" charset="0"/>
+                <a:ea typeface="JetBrains Mono" pitchFamily="34" charset="-122"/>
+                <a:cs typeface="JetBrains Mono" pitchFamily="34" charset="-120"/>
+              </a:rPr>
+              <a:t>0</a:t>
+            </a:r>
+            <a:endParaRPr lang="en-US" sz="1000" dirty="0"/>
+          </a:p>
+          <a:p>
+            <a:pPr algn="ctr" indent="0" marL="0">
+              <a:lnSpc>
+                <a:spcPts val="1800"/>
+              </a:lnSpc>
+              <a:buNone/>
+            </a:pPr>
+            <a:r>
+              <a:rPr lang="en-US" sz="1000" dirty="0">
+                <a:solidFill>
+                  <a:srgbClr val="1E8449"/>
+                </a:solidFill>
+                <a:latin typeface="JetBrains Mono" pitchFamily="34" charset="0"/>
+                <a:ea typeface="JetBrains Mono" pitchFamily="34" charset="-122"/>
+                <a:cs typeface="JetBrains Mono" pitchFamily="34" charset="-120"/>
+              </a:rPr>
+              <a:t>0</a:t>
+            </a:r>
+            <a:endParaRPr lang="en-US" sz="1000" dirty="0"/>
+          </a:p>
+          <a:p>
+            <a:pPr algn="ctr" indent="0" marL="0">
+              <a:lnSpc>
+                <a:spcPts val="1800"/>
+              </a:lnSpc>
+              <a:buNone/>
+            </a:pPr>
+            <a:r>
+              <a:rPr lang="en-US" sz="1000" dirty="0">
+                <a:solidFill>
+                  <a:srgbClr val="1E8449"/>
+                </a:solidFill>
+                <a:latin typeface="JetBrains Mono" pitchFamily="34" charset="0"/>
+                <a:ea typeface="JetBrains Mono" pitchFamily="34" charset="-122"/>
+                <a:cs typeface="JetBrains Mono" pitchFamily="34" charset="-120"/>
+              </a:rPr>
+              <a:t>1</a:t>
+            </a:r>
+            <a:endParaRPr lang="en-US" sz="1000" dirty="0"/>
+          </a:p>
+          <a:p>
+            <a:pPr algn="ctr" indent="0" marL="0">
+              <a:lnSpc>
+                <a:spcPts val="1800"/>
+              </a:lnSpc>
+              <a:buNone/>
+            </a:pPr>
+            <a:r>
+              <a:rPr lang="en-US" sz="1000" dirty="0">
+                <a:solidFill>
+                  <a:srgbClr val="1E8449"/>
+                </a:solidFill>
+                <a:latin typeface="JetBrains Mono" pitchFamily="34" charset="0"/>
+                <a:ea typeface="JetBrains Mono" pitchFamily="34" charset="-122"/>
+                <a:cs typeface="JetBrains Mono" pitchFamily="34" charset="-120"/>
+              </a:rPr>
+              <a:t>x</a:t>
+            </a:r>
+            <a:endParaRPr lang="en-US" sz="1000" dirty="0"/>
+          </a:p>
+          <a:p>
+            <a:pPr algn="ctr" indent="0" marL="0">
+              <a:lnSpc>
+                <a:spcPts val="1800"/>
+              </a:lnSpc>
+              <a:buNone/>
+            </a:pPr>
+            <a:r>
+              <a:rPr lang="en-US" sz="1000" dirty="0">
+                <a:solidFill>
+                  <a:srgbClr val="1E8449"/>
+                </a:solidFill>
+                <a:latin typeface="JetBrains Mono" pitchFamily="34" charset="0"/>
+                <a:ea typeface="JetBrains Mono" pitchFamily="34" charset="-122"/>
+                <a:cs typeface="JetBrains Mono" pitchFamily="34" charset="-120"/>
+              </a:rPr>
+              <a:t>k</a:t>
+            </a:r>
+            <a:endParaRPr lang="en-US" sz="1000" dirty="0"/>
+          </a:p>
+          <a:p>
+            <a:pPr algn="ctr" indent="0" marL="0">
+              <a:lnSpc>
+                <a:spcPts val="1800"/>
+              </a:lnSpc>
+              <a:buNone/>
+            </a:pPr>
+            <a:r>
+              <a:rPr lang="en-US" sz="1000" dirty="0">
+                <a:solidFill>
+                  <a:srgbClr val="1E8449"/>
+                </a:solidFill>
+                <a:latin typeface="JetBrains Mono" pitchFamily="34" charset="0"/>
+                <a:ea typeface="JetBrains Mono" pitchFamily="34" charset="-122"/>
+                <a:cs typeface="JetBrains Mono" pitchFamily="34" charset="-120"/>
+              </a:rPr>
+              <a:t>7</a:t>
+            </a:r>
+            <a:endParaRPr lang="en-US" sz="1000" dirty="0"/>
+          </a:p>
+          <a:p>
+            <a:pPr algn="ctr" indent="0" marL="0">
+              <a:lnSpc>
+                <a:spcPts val="1800"/>
+              </a:lnSpc>
+              <a:buNone/>
+            </a:pPr>
+            <a:r>
+              <a:rPr lang="en-US" sz="1000" dirty="0">
+                <a:solidFill>
+                  <a:srgbClr val="1E8449"/>
+                </a:solidFill>
+                <a:latin typeface="JetBrains Mono" pitchFamily="34" charset="0"/>
+                <a:ea typeface="JetBrains Mono" pitchFamily="34" charset="-122"/>
+                <a:cs typeface="JetBrains Mono" pitchFamily="34" charset="-120"/>
+              </a:rPr>
+              <a:t>0</a:t>
+            </a:r>
+            <a:endParaRPr lang="en-US" sz="1000" dirty="0"/>
+          </a:p>
+          <a:p>
+            <a:pPr algn="ctr" indent="0" marL="0">
+              <a:lnSpc>
+                <a:spcPts val="1800"/>
+              </a:lnSpc>
+              <a:buNone/>
+            </a:pPr>
+            <a:r>
+              <a:rPr lang="en-US" sz="1000" dirty="0">
+                <a:solidFill>
+                  <a:srgbClr val="1E8449"/>
+                </a:solidFill>
+                <a:latin typeface="JetBrains Mono" pitchFamily="34" charset="0"/>
+                <a:ea typeface="JetBrains Mono" pitchFamily="34" charset="-122"/>
+                <a:cs typeface="JetBrains Mono" pitchFamily="34" charset="-120"/>
+              </a:rPr>
+              <a:t>1</a:t>
+            </a:r>
+            <a:endParaRPr lang="en-US" sz="1000" dirty="0"/>
+          </a:p>
+          <a:p>
+            <a:pPr algn="ctr" indent="0" marL="0">
+              <a:lnSpc>
+                <a:spcPts val="1800"/>
+              </a:lnSpc>
+              <a:buNone/>
+            </a:pPr>
+            <a:r>
+              <a:rPr lang="en-US" sz="1000" dirty="0">
+                <a:solidFill>
+                  <a:srgbClr val="1E8449"/>
+                </a:solidFill>
+                <a:latin typeface="JetBrains Mono" pitchFamily="34" charset="0"/>
+                <a:ea typeface="JetBrains Mono" pitchFamily="34" charset="-122"/>
+                <a:cs typeface="JetBrains Mono" pitchFamily="34" charset="-120"/>
+              </a:rPr>
+              <a:t>3</a:t>
+            </a:r>
+            <a:endParaRPr lang="en-US" sz="1000" dirty="0"/>
+          </a:p>
+        </p:txBody>
+      </p:sp>
+      <p:sp>
+        <p:nvSpPr>
+          <p:cNvPr id="9" name="Text 7"/>
+          <p:cNvSpPr/>
+          <p:nvPr/>
+        </p:nvSpPr>
+        <p:spPr>
+          <a:xfrm>
+            <a:off x="2971800" y="1965960"/>
+            <a:ext cx="365760" cy="3840480"/>
+          </a:xfrm>
+          <a:prstGeom prst="rect">
+            <a:avLst/>
+          </a:prstGeom>
+          <a:noFill/>
+          <a:ln/>
+        </p:spPr>
+        <p:txBody>
+          <a:bodyPr wrap="square" lIns="0" tIns="0" rIns="0" bIns="0" rtlCol="0" anchor="t"/>
+          <a:lstStyle/>
+          <a:p>
+            <a:pPr algn="ctr" indent="0" marL="0">
+              <a:lnSpc>
+                <a:spcPts val="1800"/>
+              </a:lnSpc>
+              <a:buNone/>
+            </a:pPr>
+            <a:r>
+              <a:rPr lang="en-US" sz="1000" dirty="0">
+                <a:solidFill>
+                  <a:srgbClr val="145A32"/>
+                </a:solidFill>
+                <a:latin typeface="JetBrains Mono" pitchFamily="34" charset="0"/>
+                <a:ea typeface="JetBrains Mono" pitchFamily="34" charset="-122"/>
+                <a:cs typeface="JetBrains Mono" pitchFamily="34" charset="-120"/>
+              </a:rPr>
+              <a:t>0</a:t>
+            </a:r>
+            <a:endParaRPr lang="en-US" sz="1000" dirty="0"/>
+          </a:p>
+          <a:p>
+            <a:pPr algn="ctr" indent="0" marL="0">
+              <a:lnSpc>
+                <a:spcPts val="1800"/>
+              </a:lnSpc>
+              <a:buNone/>
+            </a:pPr>
+            <a:r>
+              <a:rPr lang="en-US" sz="1000" dirty="0">
+                <a:solidFill>
+                  <a:srgbClr val="145A32"/>
+                </a:solidFill>
+                <a:latin typeface="JetBrains Mono" pitchFamily="34" charset="0"/>
+                <a:ea typeface="JetBrains Mono" pitchFamily="34" charset="-122"/>
+                <a:cs typeface="JetBrains Mono" pitchFamily="34" charset="-120"/>
+              </a:rPr>
+              <a:t>1</a:t>
+            </a:r>
+            <a:endParaRPr lang="en-US" sz="1000" dirty="0"/>
+          </a:p>
+          <a:p>
+            <a:pPr algn="ctr" indent="0" marL="0">
+              <a:lnSpc>
+                <a:spcPts val="1800"/>
+              </a:lnSpc>
+              <a:buNone/>
+            </a:pPr>
+            <a:r>
+              <a:rPr lang="en-US" sz="1000" dirty="0">
+                <a:solidFill>
+                  <a:srgbClr val="145A32"/>
+                </a:solidFill>
+                <a:latin typeface="JetBrains Mono" pitchFamily="34" charset="0"/>
+                <a:ea typeface="JetBrains Mono" pitchFamily="34" charset="-122"/>
+                <a:cs typeface="JetBrains Mono" pitchFamily="34" charset="-120"/>
+              </a:rPr>
+              <a:t>x</a:t>
+            </a:r>
+            <a:endParaRPr lang="en-US" sz="1000" dirty="0"/>
+          </a:p>
+          <a:p>
+            <a:pPr algn="ctr" indent="0" marL="0">
+              <a:lnSpc>
+                <a:spcPts val="1800"/>
+              </a:lnSpc>
+              <a:buNone/>
+            </a:pPr>
+            <a:r>
+              <a:rPr lang="en-US" sz="1000" dirty="0">
+                <a:solidFill>
+                  <a:srgbClr val="145A32"/>
+                </a:solidFill>
+                <a:latin typeface="JetBrains Mono" pitchFamily="34" charset="0"/>
+                <a:ea typeface="JetBrains Mono" pitchFamily="34" charset="-122"/>
+                <a:cs typeface="JetBrains Mono" pitchFamily="34" charset="-120"/>
+              </a:rPr>
+              <a:t>k</a:t>
+            </a:r>
+            <a:endParaRPr lang="en-US" sz="1000" dirty="0"/>
+          </a:p>
+          <a:p>
+            <a:pPr algn="ctr" indent="0" marL="0">
+              <a:lnSpc>
+                <a:spcPts val="1800"/>
+              </a:lnSpc>
+              <a:buNone/>
+            </a:pPr>
+            <a:r>
+              <a:rPr lang="en-US" sz="1000" dirty="0">
+                <a:solidFill>
+                  <a:srgbClr val="145A32"/>
+                </a:solidFill>
+                <a:latin typeface="JetBrains Mono" pitchFamily="34" charset="0"/>
+                <a:ea typeface="JetBrains Mono" pitchFamily="34" charset="-122"/>
+                <a:cs typeface="JetBrains Mono" pitchFamily="34" charset="-120"/>
+              </a:rPr>
+              <a:t>7</a:t>
+            </a:r>
+            <a:endParaRPr lang="en-US" sz="1000" dirty="0"/>
+          </a:p>
+          <a:p>
+            <a:pPr algn="ctr" indent="0" marL="0">
+              <a:lnSpc>
+                <a:spcPts val="1800"/>
+              </a:lnSpc>
+              <a:buNone/>
+            </a:pPr>
+            <a:r>
+              <a:rPr lang="en-US" sz="1000" dirty="0">
+                <a:solidFill>
+                  <a:srgbClr val="145A32"/>
+                </a:solidFill>
+                <a:latin typeface="JetBrains Mono" pitchFamily="34" charset="0"/>
+                <a:ea typeface="JetBrains Mono" pitchFamily="34" charset="-122"/>
+                <a:cs typeface="JetBrains Mono" pitchFamily="34" charset="-120"/>
+              </a:rPr>
+              <a:t>0</a:t>
+            </a:r>
+            <a:endParaRPr lang="en-US" sz="1000" dirty="0"/>
+          </a:p>
+          <a:p>
+            <a:pPr algn="ctr" indent="0" marL="0">
+              <a:lnSpc>
+                <a:spcPts val="1800"/>
+              </a:lnSpc>
+              <a:buNone/>
+            </a:pPr>
+            <a:r>
+              <a:rPr lang="en-US" sz="1000" dirty="0">
+                <a:solidFill>
+                  <a:srgbClr val="145A32"/>
+                </a:solidFill>
+                <a:latin typeface="JetBrains Mono" pitchFamily="34" charset="0"/>
+                <a:ea typeface="JetBrains Mono" pitchFamily="34" charset="-122"/>
+                <a:cs typeface="JetBrains Mono" pitchFamily="34" charset="-120"/>
+              </a:rPr>
+              <a:t>1</a:t>
+            </a:r>
+            <a:endParaRPr lang="en-US" sz="1000" dirty="0"/>
+          </a:p>
+          <a:p>
+            <a:pPr algn="ctr" indent="0" marL="0">
+              <a:lnSpc>
+                <a:spcPts val="1800"/>
+              </a:lnSpc>
+              <a:buNone/>
+            </a:pPr>
+            <a:r>
+              <a:rPr lang="en-US" sz="1000" dirty="0">
+                <a:solidFill>
+                  <a:srgbClr val="145A32"/>
+                </a:solidFill>
+                <a:latin typeface="JetBrains Mono" pitchFamily="34" charset="0"/>
+                <a:ea typeface="JetBrains Mono" pitchFamily="34" charset="-122"/>
+                <a:cs typeface="JetBrains Mono" pitchFamily="34" charset="-120"/>
+              </a:rPr>
+              <a:t>3</a:t>
+            </a:r>
+            <a:endParaRPr lang="en-US" sz="1000" dirty="0"/>
+          </a:p>
+          <a:p>
+            <a:pPr algn="ctr" indent="0" marL="0">
+              <a:lnSpc>
+                <a:spcPts val="1800"/>
+              </a:lnSpc>
+              <a:buNone/>
+            </a:pPr>
+            <a:r>
+              <a:rPr lang="en-US" sz="1000" dirty="0">
+                <a:solidFill>
+                  <a:srgbClr val="145A32"/>
+                </a:solidFill>
+                <a:latin typeface="JetBrains Mono" pitchFamily="34" charset="0"/>
+                <a:ea typeface="JetBrains Mono" pitchFamily="34" charset="-122"/>
+                <a:cs typeface="JetBrains Mono" pitchFamily="34" charset="-120"/>
+              </a:rPr>
+              <a:t>1</a:t>
+            </a:r>
+            <a:endParaRPr lang="en-US" sz="1000" dirty="0"/>
+          </a:p>
+          <a:p>
+            <a:pPr algn="ctr" indent="0" marL="0">
+              <a:lnSpc>
+                <a:spcPts val="1800"/>
+              </a:lnSpc>
+              <a:buNone/>
+            </a:pPr>
+            <a:r>
+              <a:rPr lang="en-US" sz="1000" dirty="0">
+                <a:solidFill>
+                  <a:srgbClr val="145A32"/>
+                </a:solidFill>
+                <a:latin typeface="JetBrains Mono" pitchFamily="34" charset="0"/>
+                <a:ea typeface="JetBrains Mono" pitchFamily="34" charset="-122"/>
+                <a:cs typeface="JetBrains Mono" pitchFamily="34" charset="-120"/>
+              </a:rPr>
+              <a:t>0</a:t>
+            </a:r>
+            <a:endParaRPr lang="en-US" sz="1000" dirty="0"/>
+          </a:p>
+          <a:p>
+            <a:pPr algn="ctr" indent="0" marL="0">
+              <a:lnSpc>
+                <a:spcPts val="1800"/>
+              </a:lnSpc>
+              <a:buNone/>
+            </a:pPr>
+            <a:r>
+              <a:rPr lang="en-US" sz="1000" dirty="0">
+                <a:solidFill>
+                  <a:srgbClr val="145A32"/>
+                </a:solidFill>
+                <a:latin typeface="JetBrains Mono" pitchFamily="34" charset="0"/>
+                <a:ea typeface="JetBrains Mono" pitchFamily="34" charset="-122"/>
+                <a:cs typeface="JetBrains Mono" pitchFamily="34" charset="-120"/>
+              </a:rPr>
+              <a:t>k</a:t>
+            </a:r>
+            <a:endParaRPr lang="en-US" sz="1000" dirty="0"/>
+          </a:p>
+          <a:p>
+            <a:pPr algn="ctr" indent="0" marL="0">
+              <a:lnSpc>
+                <a:spcPts val="1800"/>
+              </a:lnSpc>
+              <a:buNone/>
+            </a:pPr>
+            <a:r>
+              <a:rPr lang="en-US" sz="1000" dirty="0">
+                <a:solidFill>
+                  <a:srgbClr val="145A32"/>
+                </a:solidFill>
+                <a:latin typeface="JetBrains Mono" pitchFamily="34" charset="0"/>
+                <a:ea typeface="JetBrains Mono" pitchFamily="34" charset="-122"/>
+                <a:cs typeface="JetBrains Mono" pitchFamily="34" charset="-120"/>
+              </a:rPr>
+              <a:t>7</a:t>
+            </a:r>
+            <a:endParaRPr lang="en-US" sz="1000" dirty="0"/>
+          </a:p>
+          <a:p>
+            <a:pPr algn="ctr" indent="0" marL="0">
+              <a:lnSpc>
+                <a:spcPts val="1800"/>
+              </a:lnSpc>
+              <a:buNone/>
+            </a:pPr>
+            <a:r>
+              <a:rPr lang="en-US" sz="1000" dirty="0">
+                <a:solidFill>
+                  <a:srgbClr val="145A32"/>
+                </a:solidFill>
+                <a:latin typeface="JetBrains Mono" pitchFamily="34" charset="0"/>
+                <a:ea typeface="JetBrains Mono" pitchFamily="34" charset="-122"/>
+                <a:cs typeface="JetBrains Mono" pitchFamily="34" charset="-120"/>
+              </a:rPr>
+              <a:t>3</a:t>
+            </a:r>
+            <a:endParaRPr lang="en-US" sz="1000" dirty="0"/>
+          </a:p>
+          <a:p>
+            <a:pPr algn="ctr" indent="0" marL="0">
+              <a:lnSpc>
+                <a:spcPts val="1800"/>
+              </a:lnSpc>
+              <a:buNone/>
+            </a:pPr>
+            <a:r>
+              <a:rPr lang="en-US" sz="1000" dirty="0">
+                <a:solidFill>
+                  <a:srgbClr val="145A32"/>
+                </a:solidFill>
+                <a:latin typeface="JetBrains Mono" pitchFamily="34" charset="0"/>
+                <a:ea typeface="JetBrains Mono" pitchFamily="34" charset="-122"/>
+                <a:cs typeface="JetBrains Mono" pitchFamily="34" charset="-120"/>
+              </a:rPr>
+              <a:t>0</a:t>
+            </a:r>
+            <a:endParaRPr lang="en-US" sz="1000" dirty="0"/>
+          </a:p>
+          <a:p>
+            <a:pPr algn="ctr" indent="0" marL="0">
+              <a:lnSpc>
+                <a:spcPts val="1800"/>
+              </a:lnSpc>
+              <a:buNone/>
+            </a:pPr>
+            <a:r>
+              <a:rPr lang="en-US" sz="1000" dirty="0">
+                <a:solidFill>
+                  <a:srgbClr val="145A32"/>
+                </a:solidFill>
+                <a:latin typeface="JetBrains Mono" pitchFamily="34" charset="0"/>
+                <a:ea typeface="JetBrains Mono" pitchFamily="34" charset="-122"/>
+                <a:cs typeface="JetBrains Mono" pitchFamily="34" charset="-120"/>
+              </a:rPr>
+              <a:t>1</a:t>
+            </a:r>
+            <a:endParaRPr lang="en-US" sz="1000" dirty="0"/>
+          </a:p>
+          <a:p>
+            <a:pPr algn="ctr" indent="0" marL="0">
+              <a:lnSpc>
+                <a:spcPts val="1800"/>
+              </a:lnSpc>
+              <a:buNone/>
+            </a:pPr>
+            <a:r>
+              <a:rPr lang="en-US" sz="1000" dirty="0">
+                <a:solidFill>
+                  <a:srgbClr val="145A32"/>
+                </a:solidFill>
+                <a:latin typeface="JetBrains Mono" pitchFamily="34" charset="0"/>
+                <a:ea typeface="JetBrains Mono" pitchFamily="34" charset="-122"/>
+                <a:cs typeface="JetBrains Mono" pitchFamily="34" charset="-120"/>
+              </a:rPr>
+              <a:t>y</a:t>
             </a:r>
             <a:endParaRPr lang="en-US" sz="1000" dirty="0"/>
           </a:p>

</xml_diff>

<commit_message>
vault backup: 2026-08-22 23:57:59
</commit_message>
<xml_diff>
--- a/0-INBOX/presentation-humanities-2026/verification-deck.pptx
+++ b/0-INBOX/presentation-humanities-2026/verification-deck.pptx
@@ -3650,7 +3650,7 @@
           </a:prstGeom>
           <a:solidFill>
             <a:srgbClr val="352A20">
-              <a:alpha val="55000"/>
+              <a:alpha val="38000"/>
             </a:srgbClr>
           </a:solidFill>
           <a:ln/>
@@ -3672,7 +3672,7 @@
           </a:prstGeom>
           <a:solidFill>
             <a:srgbClr val="352A20">
-              <a:alpha val="38000"/>
+              <a:alpha val="24000"/>
             </a:srgbClr>
           </a:solidFill>
           <a:ln/>
@@ -6580,7 +6580,7 @@
         </p:nvSpPr>
         <p:spPr>
           <a:xfrm>
-            <a:off x="685800" y="5806440"/>
+            <a:off x="685800" y="5870448"/>
             <a:ext cx="10789920" cy="320040"/>
           </a:xfrm>
           <a:prstGeom prst="rect">
@@ -7312,8 +7312,8 @@
         </p:nvSpPr>
         <p:spPr>
           <a:xfrm>
-            <a:off x="685800" y="1234440"/>
-            <a:ext cx="2496312" cy="3200400"/>
+            <a:off x="685800" y="1051560"/>
+            <a:ext cx="2496312" cy="3246120"/>
           </a:xfrm>
           <a:prstGeom prst="roundRect">
             <a:avLst>
@@ -7339,8 +7339,8 @@
         </p:nvSpPr>
         <p:spPr>
           <a:xfrm>
-            <a:off x="685800" y="1234440"/>
-            <a:ext cx="2496312" cy="3200400"/>
+            <a:off x="685800" y="1051560"/>
+            <a:ext cx="2496312" cy="3246120"/>
           </a:xfrm>
           <a:prstGeom prst="rect">
             <a:avLst/>
@@ -7395,7 +7395,7 @@
         </p:nvSpPr>
         <p:spPr>
           <a:xfrm>
-            <a:off x="749808" y="1005840"/>
+            <a:off x="749808" y="822960"/>
             <a:ext cx="457200" cy="457200"/>
           </a:xfrm>
           <a:prstGeom prst="ellipse">
@@ -7420,7 +7420,7 @@
         </p:nvSpPr>
         <p:spPr>
           <a:xfrm>
-            <a:off x="749808" y="1005840"/>
+            <a:off x="749808" y="822960"/>
             <a:ext cx="457200" cy="457200"/>
           </a:xfrm>
           <a:prstGeom prst="rect">
@@ -7459,8 +7459,8 @@
         </p:nvSpPr>
         <p:spPr>
           <a:xfrm>
-            <a:off x="3456432" y="1234440"/>
-            <a:ext cx="2496312" cy="3200400"/>
+            <a:off x="3456432" y="1051560"/>
+            <a:ext cx="2496312" cy="3246120"/>
           </a:xfrm>
           <a:prstGeom prst="roundRect">
             <a:avLst>
@@ -7486,8 +7486,8 @@
         </p:nvSpPr>
         <p:spPr>
           <a:xfrm>
-            <a:off x="3456432" y="1234440"/>
-            <a:ext cx="2496312" cy="3200400"/>
+            <a:off x="3456432" y="1051560"/>
+            <a:ext cx="2496312" cy="3246120"/>
           </a:xfrm>
           <a:prstGeom prst="rect">
             <a:avLst/>
@@ -7542,7 +7542,7 @@
         </p:nvSpPr>
         <p:spPr>
           <a:xfrm>
-            <a:off x="3520440" y="1005840"/>
+            <a:off x="3520440" y="822960"/>
             <a:ext cx="457200" cy="457200"/>
           </a:xfrm>
           <a:prstGeom prst="ellipse">
@@ -7567,7 +7567,7 @@
         </p:nvSpPr>
         <p:spPr>
           <a:xfrm>
-            <a:off x="3520440" y="1005840"/>
+            <a:off x="3520440" y="822960"/>
             <a:ext cx="457200" cy="457200"/>
           </a:xfrm>
           <a:prstGeom prst="rect">
@@ -7606,8 +7606,8 @@
         </p:nvSpPr>
         <p:spPr>
           <a:xfrm>
-            <a:off x="6227064" y="1234440"/>
-            <a:ext cx="2496312" cy="3200400"/>
+            <a:off x="6227064" y="1051560"/>
+            <a:ext cx="2496312" cy="3246120"/>
           </a:xfrm>
           <a:prstGeom prst="roundRect">
             <a:avLst>
@@ -7633,8 +7633,8 @@
         </p:nvSpPr>
         <p:spPr>
           <a:xfrm>
-            <a:off x="6227064" y="1234440"/>
-            <a:ext cx="2496312" cy="3200400"/>
+            <a:off x="6227064" y="1051560"/>
+            <a:ext cx="2496312" cy="3246120"/>
           </a:xfrm>
           <a:prstGeom prst="rect">
             <a:avLst/>
@@ -7689,7 +7689,7 @@
         </p:nvSpPr>
         <p:spPr>
           <a:xfrm>
-            <a:off x="6291072" y="1005840"/>
+            <a:off x="6291072" y="822960"/>
             <a:ext cx="457200" cy="457200"/>
           </a:xfrm>
           <a:prstGeom prst="ellipse">
@@ -7714,7 +7714,7 @@
         </p:nvSpPr>
         <p:spPr>
           <a:xfrm>
-            <a:off x="6291072" y="1005840"/>
+            <a:off x="6291072" y="822960"/>
             <a:ext cx="457200" cy="457200"/>
           </a:xfrm>
           <a:prstGeom prst="rect">
@@ -7753,8 +7753,8 @@
         </p:nvSpPr>
         <p:spPr>
           <a:xfrm>
-            <a:off x="8997696" y="1234440"/>
-            <a:ext cx="2496312" cy="3200400"/>
+            <a:off x="8997696" y="1051560"/>
+            <a:ext cx="2496312" cy="3246120"/>
           </a:xfrm>
           <a:prstGeom prst="roundRect">
             <a:avLst>
@@ -7780,8 +7780,8 @@
         </p:nvSpPr>
         <p:spPr>
           <a:xfrm>
-            <a:off x="8997696" y="1234440"/>
-            <a:ext cx="2496312" cy="3200400"/>
+            <a:off x="8997696" y="1051560"/>
+            <a:ext cx="2496312" cy="3246120"/>
           </a:xfrm>
           <a:prstGeom prst="rect">
             <a:avLst/>
@@ -7836,7 +7836,7 @@
         </p:nvSpPr>
         <p:spPr>
           <a:xfrm>
-            <a:off x="9061704" y="1005840"/>
+            <a:off x="9061704" y="822960"/>
             <a:ext cx="457200" cy="457200"/>
           </a:xfrm>
           <a:prstGeom prst="ellipse">
@@ -7861,7 +7861,7 @@
         </p:nvSpPr>
         <p:spPr>
           <a:xfrm>
-            <a:off x="9061704" y="1005840"/>
+            <a:off x="9061704" y="822960"/>
             <a:ext cx="457200" cy="457200"/>
           </a:xfrm>
           <a:prstGeom prst="rect">
@@ -11676,13 +11676,13 @@
         <p:spPr>
           <a:xfrm>
             <a:off x="2880360" y="2103120"/>
-            <a:ext cx="6263640" cy="960120"/>
+            <a:ext cx="6281928" cy="822960"/>
           </a:xfrm>
           <a:prstGeom prst="line">
             <a:avLst/>
           </a:prstGeom>
           <a:noFill/>
-          <a:ln w="15875">
+          <a:ln w="19050">
             <a:solidFill>
               <a:srgbClr val="8A8378"/>
             </a:solidFill>
@@ -11700,13 +11700,13 @@
         <p:spPr>
           <a:xfrm>
             <a:off x="2880360" y="3657600"/>
-            <a:ext cx="6263640" cy="182880"/>
+            <a:ext cx="6281928" cy="-45720"/>
           </a:xfrm>
           <a:prstGeom prst="line">
             <a:avLst/>
           </a:prstGeom>
           <a:noFill/>
-          <a:ln w="15875">
+          <a:ln w="19050">
             <a:solidFill>
               <a:srgbClr val="8A8378"/>
             </a:solidFill>
@@ -11724,13 +11724,13 @@
         <p:spPr>
           <a:xfrm>
             <a:off x="2880360" y="5349240"/>
-            <a:ext cx="6263640" cy="-731520"/>
+            <a:ext cx="6281928" cy="-1005840"/>
           </a:xfrm>
           <a:prstGeom prst="line">
             <a:avLst/>
           </a:prstGeom>
           <a:noFill/>
-          <a:ln w="15875">
+          <a:ln w="19050">
             <a:solidFill>
               <a:srgbClr val="8A8378"/>
             </a:solidFill>
@@ -11748,7 +11748,7 @@
         <p:spPr>
           <a:xfrm>
             <a:off x="9281160" y="1417320"/>
-            <a:ext cx="2103120" cy="4572000"/>
+            <a:ext cx="2103120" cy="4279392"/>
           </a:xfrm>
           <a:prstGeom prst="roundRect">
             <a:avLst>
@@ -11782,22 +11782,17 @@
         <p:spPr>
           <a:xfrm>
             <a:off x="9464040" y="1572768"/>
-            <a:ext cx="1737360" cy="137160"/>
+            <a:ext cx="1737360" cy="114300"/>
           </a:xfrm>
           <a:prstGeom prst="roundRect">
             <a:avLst>
-              <a:gd name="adj" fmla="val 13333"/>
+              <a:gd name="adj" fmla="val 16000"/>
             </a:avLst>
           </a:prstGeom>
           <a:solidFill>
-            <a:srgbClr val="FFFFFF"/>
+            <a:srgbClr val="F0DFD8"/>
           </a:solidFill>
-          <a:ln w="12700">
-            <a:solidFill>
-              <a:srgbClr val="B03A1E"/>
-            </a:solidFill>
-            <a:prstDash val="solid"/>
-          </a:ln>
+          <a:ln/>
         </p:spPr>
       </p:sp>
       <p:sp>
@@ -11808,23 +11803,18 @@
         </p:nvSpPr>
         <p:spPr>
           <a:xfrm>
-            <a:off x="9464040" y="1751076"/>
-            <a:ext cx="1737360" cy="137160"/>
+            <a:off x="9464040" y="1737360"/>
+            <a:ext cx="1737360" cy="114300"/>
           </a:xfrm>
           <a:prstGeom prst="roundRect">
             <a:avLst>
-              <a:gd name="adj" fmla="val 13333"/>
+              <a:gd name="adj" fmla="val 16000"/>
             </a:avLst>
           </a:prstGeom>
           <a:solidFill>
-            <a:srgbClr val="FFFFFF"/>
+            <a:srgbClr val="F0DFD8"/>
           </a:solidFill>
-          <a:ln w="12700">
-            <a:solidFill>
-              <a:srgbClr val="B03A1E"/>
-            </a:solidFill>
-            <a:prstDash val="solid"/>
-          </a:ln>
+          <a:ln/>
         </p:spPr>
       </p:sp>
       <p:sp>
@@ -11835,23 +11825,18 @@
         </p:nvSpPr>
         <p:spPr>
           <a:xfrm>
-            <a:off x="9464040" y="1929384"/>
-            <a:ext cx="1737360" cy="137160"/>
+            <a:off x="9464040" y="1901952"/>
+            <a:ext cx="1737360" cy="114300"/>
           </a:xfrm>
           <a:prstGeom prst="roundRect">
             <a:avLst>
-              <a:gd name="adj" fmla="val 13333"/>
+              <a:gd name="adj" fmla="val 16000"/>
             </a:avLst>
           </a:prstGeom>
           <a:solidFill>
-            <a:srgbClr val="FFFFFF"/>
+            <a:srgbClr val="F0DFD8"/>
           </a:solidFill>
-          <a:ln w="12700">
-            <a:solidFill>
-              <a:srgbClr val="B03A1E"/>
-            </a:solidFill>
-            <a:prstDash val="solid"/>
-          </a:ln>
+          <a:ln/>
         </p:spPr>
       </p:sp>
       <p:sp>
@@ -11862,23 +11847,18 @@
         </p:nvSpPr>
         <p:spPr>
           <a:xfrm>
-            <a:off x="9464040" y="2107692"/>
-            <a:ext cx="1737360" cy="137160"/>
+            <a:off x="9464040" y="2066544"/>
+            <a:ext cx="1737360" cy="114300"/>
           </a:xfrm>
           <a:prstGeom prst="roundRect">
             <a:avLst>
-              <a:gd name="adj" fmla="val 13333"/>
+              <a:gd name="adj" fmla="val 16000"/>
             </a:avLst>
           </a:prstGeom>
           <a:solidFill>
-            <a:srgbClr val="FFFFFF"/>
+            <a:srgbClr val="F0DFD8"/>
           </a:solidFill>
-          <a:ln w="12700">
-            <a:solidFill>
-              <a:srgbClr val="B03A1E"/>
-            </a:solidFill>
-            <a:prstDash val="solid"/>
-          </a:ln>
+          <a:ln/>
         </p:spPr>
       </p:sp>
       <p:sp>
@@ -11889,23 +11869,18 @@
         </p:nvSpPr>
         <p:spPr>
           <a:xfrm>
-            <a:off x="9464040" y="2286000"/>
-            <a:ext cx="1737360" cy="137160"/>
+            <a:off x="9464040" y="2231136"/>
+            <a:ext cx="1737360" cy="114300"/>
           </a:xfrm>
           <a:prstGeom prst="roundRect">
             <a:avLst>
-              <a:gd name="adj" fmla="val 13333"/>
+              <a:gd name="adj" fmla="val 16000"/>
             </a:avLst>
           </a:prstGeom>
           <a:solidFill>
-            <a:srgbClr val="FFFFFF"/>
+            <a:srgbClr val="F0DFD8"/>
           </a:solidFill>
-          <a:ln w="12700">
-            <a:solidFill>
-              <a:srgbClr val="B03A1E"/>
-            </a:solidFill>
-            <a:prstDash val="solid"/>
-          </a:ln>
+          <a:ln/>
         </p:spPr>
       </p:sp>
       <p:sp>
@@ -11916,23 +11891,18 @@
         </p:nvSpPr>
         <p:spPr>
           <a:xfrm>
-            <a:off x="9464040" y="2464308"/>
-            <a:ext cx="1737360" cy="137160"/>
+            <a:off x="9464040" y="2395728"/>
+            <a:ext cx="1737360" cy="114300"/>
           </a:xfrm>
           <a:prstGeom prst="roundRect">
             <a:avLst>
-              <a:gd name="adj" fmla="val 13333"/>
+              <a:gd name="adj" fmla="val 16000"/>
             </a:avLst>
           </a:prstGeom>
           <a:solidFill>
-            <a:srgbClr val="FFFFFF"/>
+            <a:srgbClr val="F0DFD8"/>
           </a:solidFill>
-          <a:ln w="12700">
-            <a:solidFill>
-              <a:srgbClr val="B03A1E"/>
-            </a:solidFill>
-            <a:prstDash val="solid"/>
-          </a:ln>
+          <a:ln/>
         </p:spPr>
       </p:sp>
       <p:sp>
@@ -11943,23 +11913,18 @@
         </p:nvSpPr>
         <p:spPr>
           <a:xfrm>
-            <a:off x="9464040" y="2642616"/>
-            <a:ext cx="1737360" cy="137160"/>
+            <a:off x="9464040" y="2560320"/>
+            <a:ext cx="1737360" cy="114300"/>
           </a:xfrm>
           <a:prstGeom prst="roundRect">
             <a:avLst>
-              <a:gd name="adj" fmla="val 13333"/>
+              <a:gd name="adj" fmla="val 16000"/>
             </a:avLst>
           </a:prstGeom>
           <a:solidFill>
-            <a:srgbClr val="FFFFFF"/>
+            <a:srgbClr val="F0DFD8"/>
           </a:solidFill>
-          <a:ln w="12700">
-            <a:solidFill>
-              <a:srgbClr val="B03A1E"/>
-            </a:solidFill>
-            <a:prstDash val="solid"/>
-          </a:ln>
+          <a:ln/>
         </p:spPr>
       </p:sp>
       <p:sp>
@@ -11970,23 +11935,18 @@
         </p:nvSpPr>
         <p:spPr>
           <a:xfrm>
-            <a:off x="9464040" y="2820924"/>
-            <a:ext cx="1737360" cy="137160"/>
+            <a:off x="9464040" y="2724912"/>
+            <a:ext cx="1737360" cy="114300"/>
           </a:xfrm>
           <a:prstGeom prst="roundRect">
             <a:avLst>
-              <a:gd name="adj" fmla="val 13333"/>
+              <a:gd name="adj" fmla="val 16000"/>
             </a:avLst>
           </a:prstGeom>
           <a:solidFill>
-            <a:srgbClr val="FFFFFF"/>
+            <a:srgbClr val="F0DFD8"/>
           </a:solidFill>
-          <a:ln w="12700">
-            <a:solidFill>
-              <a:srgbClr val="B03A1E"/>
-            </a:solidFill>
-            <a:prstDash val="solid"/>
-          </a:ln>
+          <a:ln/>
         </p:spPr>
       </p:sp>
       <p:sp>
@@ -11997,23 +11957,18 @@
         </p:nvSpPr>
         <p:spPr>
           <a:xfrm>
-            <a:off x="9464040" y="2999232"/>
-            <a:ext cx="1737360" cy="137160"/>
+            <a:off x="9464040" y="2889504"/>
+            <a:ext cx="1737360" cy="114300"/>
           </a:xfrm>
           <a:prstGeom prst="roundRect">
             <a:avLst>
-              <a:gd name="adj" fmla="val 13333"/>
+              <a:gd name="adj" fmla="val 16000"/>
             </a:avLst>
           </a:prstGeom>
           <a:solidFill>
-            <a:srgbClr val="FFFFFF"/>
+            <a:srgbClr val="F0DFD8"/>
           </a:solidFill>
-          <a:ln w="12700">
-            <a:solidFill>
-              <a:srgbClr val="B03A1E"/>
-            </a:solidFill>
-            <a:prstDash val="solid"/>
-          </a:ln>
+          <a:ln/>
         </p:spPr>
       </p:sp>
       <p:sp>
@@ -12024,23 +11979,18 @@
         </p:nvSpPr>
         <p:spPr>
           <a:xfrm>
-            <a:off x="9464040" y="3177540"/>
-            <a:ext cx="1737360" cy="137160"/>
+            <a:off x="9464040" y="3054096"/>
+            <a:ext cx="1737360" cy="114300"/>
           </a:xfrm>
           <a:prstGeom prst="roundRect">
             <a:avLst>
-              <a:gd name="adj" fmla="val 13333"/>
+              <a:gd name="adj" fmla="val 16000"/>
             </a:avLst>
           </a:prstGeom>
           <a:solidFill>
-            <a:srgbClr val="FFFFFF"/>
+            <a:srgbClr val="F0DFD8"/>
           </a:solidFill>
-          <a:ln w="12700">
-            <a:solidFill>
-              <a:srgbClr val="B03A1E"/>
-            </a:solidFill>
-            <a:prstDash val="solid"/>
-          </a:ln>
+          <a:ln/>
         </p:spPr>
       </p:sp>
       <p:sp>
@@ -12051,23 +12001,18 @@
         </p:nvSpPr>
         <p:spPr>
           <a:xfrm>
-            <a:off x="9464040" y="3355848"/>
-            <a:ext cx="1737360" cy="137160"/>
+            <a:off x="9464040" y="3218688"/>
+            <a:ext cx="1737360" cy="114300"/>
           </a:xfrm>
           <a:prstGeom prst="roundRect">
             <a:avLst>
-              <a:gd name="adj" fmla="val 13333"/>
+              <a:gd name="adj" fmla="val 16000"/>
             </a:avLst>
           </a:prstGeom>
           <a:solidFill>
-            <a:srgbClr val="FFFFFF"/>
+            <a:srgbClr val="F0DFD8"/>
           </a:solidFill>
-          <a:ln w="12700">
-            <a:solidFill>
-              <a:srgbClr val="B03A1E"/>
-            </a:solidFill>
-            <a:prstDash val="solid"/>
-          </a:ln>
+          <a:ln/>
         </p:spPr>
       </p:sp>
       <p:sp>
@@ -12078,23 +12023,18 @@
         </p:nvSpPr>
         <p:spPr>
           <a:xfrm>
-            <a:off x="9464040" y="3534156"/>
-            <a:ext cx="1737360" cy="137160"/>
+            <a:off x="9464040" y="3383280"/>
+            <a:ext cx="1737360" cy="114300"/>
           </a:xfrm>
           <a:prstGeom prst="roundRect">
             <a:avLst>
-              <a:gd name="adj" fmla="val 13333"/>
+              <a:gd name="adj" fmla="val 16000"/>
             </a:avLst>
           </a:prstGeom>
           <a:solidFill>
-            <a:srgbClr val="FFFFFF"/>
+            <a:srgbClr val="F0DFD8"/>
           </a:solidFill>
-          <a:ln w="12700">
-            <a:solidFill>
-              <a:srgbClr val="B03A1E"/>
-            </a:solidFill>
-            <a:prstDash val="solid"/>
-          </a:ln>
+          <a:ln/>
         </p:spPr>
       </p:sp>
       <p:sp>
@@ -12105,23 +12045,18 @@
         </p:nvSpPr>
         <p:spPr>
           <a:xfrm>
-            <a:off x="9464040" y="3712464"/>
-            <a:ext cx="1737360" cy="137160"/>
+            <a:off x="9464040" y="3547872"/>
+            <a:ext cx="1737360" cy="114300"/>
           </a:xfrm>
           <a:prstGeom prst="roundRect">
             <a:avLst>
-              <a:gd name="adj" fmla="val 13333"/>
+              <a:gd name="adj" fmla="val 16000"/>
             </a:avLst>
           </a:prstGeom>
           <a:solidFill>
-            <a:srgbClr val="FFFFFF"/>
+            <a:srgbClr val="F0DFD8"/>
           </a:solidFill>
-          <a:ln w="12700">
-            <a:solidFill>
-              <a:srgbClr val="B03A1E"/>
-            </a:solidFill>
-            <a:prstDash val="solid"/>
-          </a:ln>
+          <a:ln/>
         </p:spPr>
       </p:sp>
       <p:sp>
@@ -12132,23 +12067,18 @@
         </p:nvSpPr>
         <p:spPr>
           <a:xfrm>
-            <a:off x="9464040" y="3890772"/>
-            <a:ext cx="1737360" cy="137160"/>
+            <a:off x="9464040" y="3712464"/>
+            <a:ext cx="1737360" cy="114300"/>
           </a:xfrm>
           <a:prstGeom prst="roundRect">
             <a:avLst>
-              <a:gd name="adj" fmla="val 13333"/>
+              <a:gd name="adj" fmla="val 16000"/>
             </a:avLst>
           </a:prstGeom>
           <a:solidFill>
-            <a:srgbClr val="FFFFFF"/>
+            <a:srgbClr val="F0DFD8"/>
           </a:solidFill>
-          <a:ln w="12700">
-            <a:solidFill>
-              <a:srgbClr val="B03A1E"/>
-            </a:solidFill>
-            <a:prstDash val="solid"/>
-          </a:ln>
+          <a:ln/>
         </p:spPr>
       </p:sp>
       <p:sp>
@@ -12159,23 +12089,18 @@
         </p:nvSpPr>
         <p:spPr>
           <a:xfrm>
-            <a:off x="9464040" y="4069080"/>
-            <a:ext cx="1737360" cy="137160"/>
+            <a:off x="9464040" y="3877056"/>
+            <a:ext cx="1737360" cy="114300"/>
           </a:xfrm>
           <a:prstGeom prst="roundRect">
             <a:avLst>
-              <a:gd name="adj" fmla="val 13333"/>
+              <a:gd name="adj" fmla="val 16000"/>
             </a:avLst>
           </a:prstGeom>
           <a:solidFill>
-            <a:srgbClr val="FFFFFF"/>
+            <a:srgbClr val="F0DFD8"/>
           </a:solidFill>
-          <a:ln w="12700">
-            <a:solidFill>
-              <a:srgbClr val="B03A1E"/>
-            </a:solidFill>
-            <a:prstDash val="solid"/>
-          </a:ln>
+          <a:ln/>
         </p:spPr>
       </p:sp>
       <p:sp>
@@ -12186,23 +12111,18 @@
         </p:nvSpPr>
         <p:spPr>
           <a:xfrm>
-            <a:off x="9464040" y="4247388"/>
-            <a:ext cx="1737360" cy="137160"/>
+            <a:off x="9464040" y="4041648"/>
+            <a:ext cx="1737360" cy="114300"/>
           </a:xfrm>
           <a:prstGeom prst="roundRect">
             <a:avLst>
-              <a:gd name="adj" fmla="val 13333"/>
+              <a:gd name="adj" fmla="val 16000"/>
             </a:avLst>
           </a:prstGeom>
           <a:solidFill>
-            <a:srgbClr val="FFFFFF"/>
+            <a:srgbClr val="F0DFD8"/>
           </a:solidFill>
-          <a:ln w="12700">
-            <a:solidFill>
-              <a:srgbClr val="B03A1E"/>
-            </a:solidFill>
-            <a:prstDash val="solid"/>
-          </a:ln>
+          <a:ln/>
         </p:spPr>
       </p:sp>
       <p:sp>
@@ -12213,23 +12133,18 @@
         </p:nvSpPr>
         <p:spPr>
           <a:xfrm>
-            <a:off x="9464040" y="4425696"/>
-            <a:ext cx="1737360" cy="137160"/>
+            <a:off x="9464040" y="4206240"/>
+            <a:ext cx="1737360" cy="114300"/>
           </a:xfrm>
           <a:prstGeom prst="roundRect">
             <a:avLst>
-              <a:gd name="adj" fmla="val 13333"/>
+              <a:gd name="adj" fmla="val 16000"/>
             </a:avLst>
           </a:prstGeom>
           <a:solidFill>
-            <a:srgbClr val="FFFFFF"/>
+            <a:srgbClr val="F0DFD8"/>
           </a:solidFill>
-          <a:ln w="12700">
-            <a:solidFill>
-              <a:srgbClr val="B03A1E"/>
-            </a:solidFill>
-            <a:prstDash val="solid"/>
-          </a:ln>
+          <a:ln/>
         </p:spPr>
       </p:sp>
       <p:sp>
@@ -12240,23 +12155,18 @@
         </p:nvSpPr>
         <p:spPr>
           <a:xfrm>
-            <a:off x="9464040" y="4604004"/>
-            <a:ext cx="1737360" cy="137160"/>
+            <a:off x="9464040" y="4370832"/>
+            <a:ext cx="1737360" cy="114300"/>
           </a:xfrm>
           <a:prstGeom prst="roundRect">
             <a:avLst>
-              <a:gd name="adj" fmla="val 13333"/>
+              <a:gd name="adj" fmla="val 16000"/>
             </a:avLst>
           </a:prstGeom>
           <a:solidFill>
-            <a:srgbClr val="FFFFFF"/>
+            <a:srgbClr val="F0DFD8"/>
           </a:solidFill>
-          <a:ln w="12700">
-            <a:solidFill>
-              <a:srgbClr val="B03A1E"/>
-            </a:solidFill>
-            <a:prstDash val="solid"/>
-          </a:ln>
+          <a:ln/>
         </p:spPr>
       </p:sp>
       <p:sp>
@@ -12267,23 +12177,18 @@
         </p:nvSpPr>
         <p:spPr>
           <a:xfrm>
-            <a:off x="9464040" y="4782312"/>
-            <a:ext cx="1737360" cy="137160"/>
+            <a:off x="9464040" y="4535424"/>
+            <a:ext cx="1737360" cy="114300"/>
           </a:xfrm>
           <a:prstGeom prst="roundRect">
             <a:avLst>
-              <a:gd name="adj" fmla="val 13333"/>
+              <a:gd name="adj" fmla="val 16000"/>
             </a:avLst>
           </a:prstGeom>
           <a:solidFill>
-            <a:srgbClr val="FFFFFF"/>
+            <a:srgbClr val="F0DFD8"/>
           </a:solidFill>
-          <a:ln w="12700">
-            <a:solidFill>
-              <a:srgbClr val="B03A1E"/>
-            </a:solidFill>
-            <a:prstDash val="solid"/>
-          </a:ln>
+          <a:ln/>
         </p:spPr>
       </p:sp>
       <p:sp>
@@ -12294,23 +12199,18 @@
         </p:nvSpPr>
         <p:spPr>
           <a:xfrm>
-            <a:off x="9464040" y="4960620"/>
-            <a:ext cx="1737360" cy="137160"/>
+            <a:off x="9464040" y="4700016"/>
+            <a:ext cx="1737360" cy="114300"/>
           </a:xfrm>
           <a:prstGeom prst="roundRect">
             <a:avLst>
-              <a:gd name="adj" fmla="val 13333"/>
+              <a:gd name="adj" fmla="val 16000"/>
             </a:avLst>
           </a:prstGeom>
           <a:solidFill>
-            <a:srgbClr val="FFFFFF"/>
+            <a:srgbClr val="F0DFD8"/>
           </a:solidFill>
-          <a:ln w="12700">
-            <a:solidFill>
-              <a:srgbClr val="B03A1E"/>
-            </a:solidFill>
-            <a:prstDash val="solid"/>
-          </a:ln>
+          <a:ln/>
         </p:spPr>
       </p:sp>
       <p:sp>
@@ -12321,23 +12221,18 @@
         </p:nvSpPr>
         <p:spPr>
           <a:xfrm>
-            <a:off x="9464040" y="5138928"/>
-            <a:ext cx="1737360" cy="137160"/>
+            <a:off x="9464040" y="4864608"/>
+            <a:ext cx="1737360" cy="114300"/>
           </a:xfrm>
           <a:prstGeom prst="roundRect">
             <a:avLst>
-              <a:gd name="adj" fmla="val 13333"/>
+              <a:gd name="adj" fmla="val 16000"/>
             </a:avLst>
           </a:prstGeom>
           <a:solidFill>
-            <a:srgbClr val="FFFFFF"/>
+            <a:srgbClr val="F0DFD8"/>
           </a:solidFill>
-          <a:ln w="12700">
-            <a:solidFill>
-              <a:srgbClr val="B03A1E"/>
-            </a:solidFill>
-            <a:prstDash val="solid"/>
-          </a:ln>
+          <a:ln/>
         </p:spPr>
       </p:sp>
       <p:sp>
@@ -12348,23 +12243,18 @@
         </p:nvSpPr>
         <p:spPr>
           <a:xfrm>
-            <a:off x="9464040" y="5317236"/>
-            <a:ext cx="1737360" cy="137160"/>
+            <a:off x="9464040" y="5029200"/>
+            <a:ext cx="1737360" cy="114300"/>
           </a:xfrm>
           <a:prstGeom prst="roundRect">
             <a:avLst>
-              <a:gd name="adj" fmla="val 13333"/>
+              <a:gd name="adj" fmla="val 16000"/>
             </a:avLst>
           </a:prstGeom>
           <a:solidFill>
-            <a:srgbClr val="FFFFFF"/>
+            <a:srgbClr val="B03A1E"/>
           </a:solidFill>
-          <a:ln w="12700">
-            <a:solidFill>
-              <a:srgbClr val="B03A1E"/>
-            </a:solidFill>
-            <a:prstDash val="solid"/>
-          </a:ln>
+          <a:ln/>
         </p:spPr>
       </p:sp>
       <p:sp>
@@ -12375,23 +12265,18 @@
         </p:nvSpPr>
         <p:spPr>
           <a:xfrm>
-            <a:off x="9464040" y="5495544"/>
-            <a:ext cx="1737360" cy="137160"/>
+            <a:off x="9464040" y="5193792"/>
+            <a:ext cx="1737360" cy="114300"/>
           </a:xfrm>
           <a:prstGeom prst="roundRect">
             <a:avLst>
-              <a:gd name="adj" fmla="val 13333"/>
+              <a:gd name="adj" fmla="val 16000"/>
             </a:avLst>
           </a:prstGeom>
           <a:solidFill>
-            <a:srgbClr val="FFFFFF"/>
+            <a:srgbClr val="B03A1E"/>
           </a:solidFill>
-          <a:ln w="12700">
-            <a:solidFill>
-              <a:srgbClr val="B03A1E"/>
-            </a:solidFill>
-            <a:prstDash val="solid"/>
-          </a:ln>
+          <a:ln/>
         </p:spPr>
       </p:sp>
       <p:sp>
@@ -12402,23 +12287,18 @@
         </p:nvSpPr>
         <p:spPr>
           <a:xfrm>
-            <a:off x="9464040" y="5673852"/>
-            <a:ext cx="1737360" cy="137160"/>
+            <a:off x="9464040" y="5358384"/>
+            <a:ext cx="1737360" cy="114300"/>
           </a:xfrm>
           <a:prstGeom prst="roundRect">
             <a:avLst>
-              <a:gd name="adj" fmla="val 13333"/>
+              <a:gd name="adj" fmla="val 16000"/>
             </a:avLst>
           </a:prstGeom>
           <a:solidFill>
-            <a:srgbClr val="FFFFFF"/>
+            <a:srgbClr val="B03A1E"/>
           </a:solidFill>
-          <a:ln w="12700">
-            <a:solidFill>
-              <a:srgbClr val="B03A1E"/>
-            </a:solidFill>
-            <a:prstDash val="solid"/>
-          </a:ln>
+          <a:ln/>
         </p:spPr>
       </p:sp>
       <p:sp>
@@ -12429,7 +12309,7 @@
         </p:nvSpPr>
         <p:spPr>
           <a:xfrm>
-            <a:off x="8778240" y="6035040"/>
+            <a:off x="8778240" y="5806440"/>
             <a:ext cx="3108960" cy="502920"/>
           </a:xfrm>
           <a:prstGeom prst="rect">
@@ -17282,7 +17162,7 @@
         </p:nvSpPr>
         <p:spPr>
           <a:xfrm>
-            <a:off x="685800" y="320040"/>
+            <a:off x="685800" y="411480"/>
             <a:ext cx="10789920" cy="365760"/>
           </a:xfrm>
           <a:prstGeom prst="rect">
@@ -17321,7 +17201,7 @@
         </p:nvSpPr>
         <p:spPr>
           <a:xfrm>
-            <a:off x="685800" y="731520"/>
+            <a:off x="685800" y="822960"/>
             <a:ext cx="10789920" cy="365760"/>
           </a:xfrm>
           <a:prstGeom prst="rect">
@@ -17658,15 +17538,15 @@
         </p:nvSpPr>
         <p:spPr>
           <a:xfrm>
-            <a:off x="2743200" y="4297680"/>
-            <a:ext cx="6766560" cy="2926080"/>
+            <a:off x="2377440" y="4709160"/>
+            <a:ext cx="7498080" cy="2103120"/>
           </a:xfrm>
           <a:prstGeom prst="ellipse">
             <a:avLst/>
           </a:prstGeom>
           <a:solidFill>
             <a:srgbClr val="352A20">
-              <a:alpha val="45000"/>
+              <a:alpha val="32000"/>
             </a:srgbClr>
           </a:solidFill>
           <a:ln/>
@@ -17759,7 +17639,7 @@
           </a:prstGeom>
           <a:solidFill>
             <a:srgbClr val="352A20">
-              <a:alpha val="55000"/>
+              <a:alpha val="38000"/>
             </a:srgbClr>
           </a:solidFill>
           <a:ln/>
@@ -17781,7 +17661,7 @@
           </a:prstGeom>
           <a:solidFill>
             <a:srgbClr val="352A20">
-              <a:alpha val="38000"/>
+              <a:alpha val="24000"/>
             </a:srgbClr>
           </a:solidFill>
           <a:ln/>
@@ -19605,8 +19485,8 @@
         </p:nvSpPr>
         <p:spPr>
           <a:xfrm>
-            <a:off x="11128248" y="5248656"/>
-            <a:ext cx="2194560" cy="310896"/>
+            <a:off x="2953512" y="5248656"/>
+            <a:ext cx="2743200" cy="310896"/>
           </a:xfrm>
           <a:prstGeom prst="rect">
             <a:avLst/>
@@ -19624,7 +19504,7 @@
             <a:r>
               <a:rPr lang="en-US" sz="1050" b="1" dirty="0">
                 <a:solidFill>
-                  <a:srgbClr val="B03A1E"/>
+                  <a:srgbClr val="FFFFFF"/>
                 </a:solidFill>
                 <a:latin typeface="JetBrains Mono" pitchFamily="34" charset="0"/>
                 <a:ea typeface="JetBrains Mono" pitchFamily="34" charset="-122"/>
@@ -21262,28 +21142,6 @@
         </p:nvSpPr>
         <p:spPr>
           <a:xfrm>
-            <a:off x="4892040" y="4606290"/>
-            <a:ext cx="6035040" cy="925830"/>
-          </a:xfrm>
-          <a:prstGeom prst="roundRect">
-            <a:avLst>
-              <a:gd name="adj" fmla="val 3951"/>
-            </a:avLst>
-          </a:prstGeom>
-          <a:solidFill>
-            <a:srgbClr val="F0DFD8"/>
-          </a:solidFill>
-          <a:ln/>
-        </p:spPr>
-      </p:sp>
-      <p:sp>
-        <p:nvSpPr>
-          <p:cNvPr id="4" name="Shape 2"/>
-          <p:cNvSpPr/>
-          <p:nvPr/>
-        </p:nvSpPr>
-        <p:spPr>
-          <a:xfrm>
             <a:off x="2514600" y="2395408"/>
             <a:ext cx="1554480" cy="3136712"/>
           </a:xfrm>
@@ -21300,14 +21158,14 @@
       </p:sp>
       <p:sp>
         <p:nvSpPr>
-          <p:cNvPr id="5" name="Text 3"/>
-          <p:cNvSpPr/>
-          <p:nvPr/>
-        </p:nvSpPr>
-        <p:spPr>
-          <a:xfrm>
-            <a:off x="2148840" y="1983928"/>
-            <a:ext cx="2286000" cy="365760"/>
+          <p:cNvPr id="4" name="Text 2"/>
+          <p:cNvSpPr/>
+          <p:nvPr/>
+        </p:nvSpPr>
+        <p:spPr>
+          <a:xfrm>
+            <a:off x="2514600" y="2505136"/>
+            <a:ext cx="1554480" cy="384048"/>
           </a:xfrm>
           <a:prstGeom prst="rect">
             <a:avLst/>
@@ -21339,7 +21197,7 @@
       </p:sp>
       <p:sp>
         <p:nvSpPr>
-          <p:cNvPr id="6" name="Text 4"/>
+          <p:cNvPr id="5" name="Text 3"/>
           <p:cNvSpPr/>
           <p:nvPr/>
         </p:nvSpPr>
@@ -21378,7 +21236,7 @@
       </p:sp>
       <p:sp>
         <p:nvSpPr>
-          <p:cNvPr id="7" name="Shape 5"/>
+          <p:cNvPr id="6" name="Shape 4"/>
           <p:cNvSpPr/>
           <p:nvPr/>
         </p:nvSpPr>
@@ -21400,14 +21258,14 @@
       </p:sp>
       <p:sp>
         <p:nvSpPr>
-          <p:cNvPr id="8" name="Text 6"/>
-          <p:cNvSpPr/>
-          <p:nvPr/>
-        </p:nvSpPr>
-        <p:spPr>
-          <a:xfrm>
-            <a:off x="4956048" y="4472559"/>
-            <a:ext cx="2286000" cy="365760"/>
+          <p:cNvPr id="7" name="Text 5"/>
+          <p:cNvSpPr/>
+          <p:nvPr/>
+        </p:nvSpPr>
+        <p:spPr>
+          <a:xfrm>
+            <a:off x="5321808" y="4993767"/>
+            <a:ext cx="1554480" cy="384048"/>
           </a:xfrm>
           <a:prstGeom prst="rect">
             <a:avLst/>
@@ -21425,7 +21283,7 @@
             <a:r>
               <a:rPr lang="en-US" sz="1700" b="1" dirty="0">
                 <a:solidFill>
-                  <a:srgbClr val="B03A1E"/>
+                  <a:srgbClr val="FFFFFF"/>
                 </a:solidFill>
                 <a:latin typeface="Archivo" pitchFamily="34" charset="0"/>
                 <a:ea typeface="Archivo" pitchFamily="34" charset="-122"/>
@@ -21439,7 +21297,7 @@
       </p:sp>
       <p:sp>
         <p:nvSpPr>
-          <p:cNvPr id="9" name="Text 7"/>
+          <p:cNvPr id="8" name="Text 6"/>
           <p:cNvSpPr/>
           <p:nvPr/>
         </p:nvSpPr>
@@ -21478,7 +21336,7 @@
       </p:sp>
       <p:sp>
         <p:nvSpPr>
-          <p:cNvPr id="10" name="Shape 8"/>
+          <p:cNvPr id="9" name="Shape 7"/>
           <p:cNvSpPr/>
           <p:nvPr/>
         </p:nvSpPr>
@@ -21500,14 +21358,14 @@
       </p:sp>
       <p:sp>
         <p:nvSpPr>
-          <p:cNvPr id="11" name="Text 9"/>
-          <p:cNvSpPr/>
-          <p:nvPr/>
-        </p:nvSpPr>
-        <p:spPr>
-          <a:xfrm>
-            <a:off x="7763256" y="4509592"/>
-            <a:ext cx="2286000" cy="365760"/>
+          <p:cNvPr id="10" name="Text 8"/>
+          <p:cNvSpPr/>
+          <p:nvPr/>
+        </p:nvSpPr>
+        <p:spPr>
+          <a:xfrm>
+            <a:off x="8129016" y="5030800"/>
+            <a:ext cx="1554480" cy="384048"/>
           </a:xfrm>
           <a:prstGeom prst="rect">
             <a:avLst/>
@@ -21525,7 +21383,7 @@
             <a:r>
               <a:rPr lang="en-US" sz="1700" b="1" dirty="0">
                 <a:solidFill>
-                  <a:srgbClr val="B03A1E"/>
+                  <a:srgbClr val="FFFFFF"/>
                 </a:solidFill>
                 <a:latin typeface="Archivo" pitchFamily="34" charset="0"/>
                 <a:ea typeface="Archivo" pitchFamily="34" charset="-122"/>
@@ -21539,7 +21397,7 @@
       </p:sp>
       <p:sp>
         <p:nvSpPr>
-          <p:cNvPr id="12" name="Text 10"/>
+          <p:cNvPr id="11" name="Text 9"/>
           <p:cNvSpPr/>
           <p:nvPr/>
         </p:nvSpPr>
@@ -21578,14 +21436,14 @@
       </p:sp>
       <p:sp>
         <p:nvSpPr>
-          <p:cNvPr id="13" name="Shape 11"/>
+          <p:cNvPr id="12" name="Shape 10"/>
           <p:cNvSpPr/>
           <p:nvPr/>
         </p:nvSpPr>
         <p:spPr>
           <a:xfrm>
             <a:off x="2103120" y="4606290"/>
-            <a:ext cx="8961120" cy="0"/>
+            <a:ext cx="7452360" cy="0"/>
           </a:xfrm>
           <a:prstGeom prst="line">
             <a:avLst/>
@@ -21601,14 +21459,14 @@
       </p:sp>
       <p:sp>
         <p:nvSpPr>
-          <p:cNvPr id="14" name="Shape 12"/>
-          <p:cNvSpPr/>
-          <p:nvPr/>
-        </p:nvSpPr>
-        <p:spPr>
-          <a:xfrm>
-            <a:off x="9006840" y="4222242"/>
-            <a:ext cx="2057400" cy="365760"/>
+          <p:cNvPr id="13" name="Shape 11"/>
+          <p:cNvSpPr/>
+          <p:nvPr/>
+        </p:nvSpPr>
+        <p:spPr>
+          <a:xfrm>
+            <a:off x="9692640" y="4368546"/>
+            <a:ext cx="1810512" cy="475488"/>
           </a:xfrm>
           <a:prstGeom prst="roundRect">
             <a:avLst>
@@ -21628,14 +21486,14 @@
       </p:sp>
       <p:sp>
         <p:nvSpPr>
-          <p:cNvPr id="15" name="Text 13"/>
-          <p:cNvSpPr/>
-          <p:nvPr/>
-        </p:nvSpPr>
-        <p:spPr>
-          <a:xfrm>
-            <a:off x="9006840" y="4222242"/>
-            <a:ext cx="2057400" cy="365760"/>
+          <p:cNvPr id="14" name="Text 12"/>
+          <p:cNvSpPr/>
+          <p:nvPr/>
+        </p:nvSpPr>
+        <p:spPr>
+          <a:xfrm>
+            <a:off x="9692640" y="4368546"/>
+            <a:ext cx="1810512" cy="475488"/>
           </a:xfrm>
           <a:prstGeom prst="rect">
             <a:avLst/>
@@ -21651,7 +21509,7 @@
               <a:buNone/>
             </a:pPr>
             <a:r>
-              <a:rPr lang="en-US" sz="1000" dirty="0">
+              <a:rPr lang="en-US" sz="950" dirty="0">
                 <a:solidFill>
                   <a:srgbClr val="1A1A1A"/>
                 </a:solidFill>
@@ -21659,15 +21517,32 @@
                 <a:ea typeface="JetBrains Mono" pitchFamily="34" charset="-122"/>
                 <a:cs typeface="JetBrains Mono" pitchFamily="34" charset="-120"/>
               </a:rPr>
-              <a:t>random guessing — 25%</a:t>
-            </a:r>
-            <a:endParaRPr lang="en-US" sz="1000" dirty="0"/>
-          </a:p>
-        </p:txBody>
-      </p:sp>
-      <p:sp>
-        <p:nvSpPr>
-          <p:cNvPr id="16" name="Text 14"/>
+              <a:t>random guessing</a:t>
+            </a:r>
+            <a:endParaRPr lang="en-US" sz="950" dirty="0"/>
+          </a:p>
+          <a:p>
+            <a:pPr algn="ctr" indent="0" marL="0">
+              <a:buNone/>
+            </a:pPr>
+            <a:r>
+              <a:rPr lang="en-US" sz="950" dirty="0">
+                <a:solidFill>
+                  <a:srgbClr val="1A1A1A"/>
+                </a:solidFill>
+                <a:latin typeface="JetBrains Mono" pitchFamily="34" charset="0"/>
+                <a:ea typeface="JetBrains Mono" pitchFamily="34" charset="-122"/>
+                <a:cs typeface="JetBrains Mono" pitchFamily="34" charset="-120"/>
+              </a:rPr>
+              <a:t>25%</a:t>
+            </a:r>
+            <a:endParaRPr lang="en-US" sz="950" dirty="0"/>
+          </a:p>
+        </p:txBody>
+      </p:sp>
+      <p:sp>
+        <p:nvSpPr>
+          <p:cNvPr id="15" name="Text 13"/>
           <p:cNvSpPr/>
           <p:nvPr/>
         </p:nvSpPr>
@@ -21706,7 +21581,7 @@
       </p:sp>
       <p:sp>
         <p:nvSpPr>
-          <p:cNvPr id="17" name="Text 15"/>
+          <p:cNvPr id="16" name="Text 14"/>
           <p:cNvSpPr/>
           <p:nvPr/>
         </p:nvSpPr>
@@ -21783,7 +21658,7 @@
         </p:nvSpPr>
         <p:spPr>
           <a:xfrm>
-            <a:off x="1673352" y="2084832"/>
+            <a:off x="1490472" y="2084832"/>
             <a:ext cx="2414016" cy="2414016"/>
           </a:xfrm>
           <a:prstGeom prst="ellipse">
@@ -21805,7 +21680,7 @@
         </p:nvSpPr>
         <p:spPr>
           <a:xfrm>
-            <a:off x="8101584" y="2084832"/>
+            <a:off x="8284464" y="2084832"/>
             <a:ext cx="2414016" cy="2414016"/>
           </a:xfrm>
           <a:prstGeom prst="ellipse">
@@ -21827,7 +21702,7 @@
         </p:nvSpPr>
         <p:spPr>
           <a:xfrm rot="10800000">
-            <a:off x="2743200" y="1947672"/>
+            <a:off x="2560320" y="1947672"/>
             <a:ext cx="274320" cy="274320"/>
           </a:xfrm>
           <a:prstGeom prst="triangle">
@@ -21847,7 +21722,7 @@
         </p:nvSpPr>
         <p:spPr>
           <a:xfrm rot="-5400000">
-            <a:off x="3950208" y="3154680"/>
+            <a:off x="3767328" y="3154680"/>
             <a:ext cx="274320" cy="274320"/>
           </a:xfrm>
           <a:prstGeom prst="triangle">
@@ -21867,7 +21742,7 @@
         </p:nvSpPr>
         <p:spPr>
           <a:xfrm>
-            <a:off x="2743200" y="4361688"/>
+            <a:off x="2560320" y="4361688"/>
             <a:ext cx="274320" cy="274320"/>
           </a:xfrm>
           <a:prstGeom prst="triangle">
@@ -21887,7 +21762,7 @@
         </p:nvSpPr>
         <p:spPr>
           <a:xfrm rot="5400000">
-            <a:off x="1536192" y="3154680"/>
+            <a:off x="1353312" y="3154680"/>
             <a:ext cx="274320" cy="274320"/>
           </a:xfrm>
           <a:prstGeom prst="triangle">
@@ -21907,7 +21782,7 @@
         </p:nvSpPr>
         <p:spPr>
           <a:xfrm>
-            <a:off x="9171432" y="1947672"/>
+            <a:off x="9354312" y="1947672"/>
             <a:ext cx="274320" cy="274320"/>
           </a:xfrm>
           <a:prstGeom prst="triangle">
@@ -21927,7 +21802,7 @@
         </p:nvSpPr>
         <p:spPr>
           <a:xfrm rot="5400000">
-            <a:off x="10378440" y="3154680"/>
+            <a:off x="10561320" y="3154680"/>
             <a:ext cx="274320" cy="274320"/>
           </a:xfrm>
           <a:prstGeom prst="triangle">
@@ -21947,7 +21822,7 @@
         </p:nvSpPr>
         <p:spPr>
           <a:xfrm rot="10800000">
-            <a:off x="9171432" y="4361688"/>
+            <a:off x="9354312" y="4361688"/>
             <a:ext cx="274320" cy="274320"/>
           </a:xfrm>
           <a:prstGeom prst="triangle">
@@ -21967,7 +21842,7 @@
         </p:nvSpPr>
         <p:spPr>
           <a:xfrm rot="-5400000">
-            <a:off x="7964424" y="3154680"/>
+            <a:off x="8147304" y="3154680"/>
             <a:ext cx="274320" cy="274320"/>
           </a:xfrm>
           <a:prstGeom prst="triangle">
@@ -21987,7 +21862,7 @@
         </p:nvSpPr>
         <p:spPr>
           <a:xfrm>
-            <a:off x="1325880" y="1243584"/>
+            <a:off x="1143000" y="1243584"/>
             <a:ext cx="3108960" cy="685800"/>
           </a:xfrm>
           <a:prstGeom prst="rect">
@@ -22026,8 +21901,8 @@
         </p:nvSpPr>
         <p:spPr>
           <a:xfrm>
-            <a:off x="4233672" y="2948940"/>
-            <a:ext cx="1417320" cy="685800"/>
+            <a:off x="4041648" y="2948940"/>
+            <a:ext cx="1234440" cy="685800"/>
           </a:xfrm>
           <a:prstGeom prst="rect">
             <a:avLst/>
@@ -22043,7 +21918,7 @@
               <a:buNone/>
             </a:pPr>
             <a:r>
-              <a:rPr lang="en-US" sz="1200" dirty="0">
+              <a:rPr lang="en-US" sz="1150" dirty="0">
                 <a:solidFill>
                   <a:srgbClr val="1A1A1A"/>
                 </a:solidFill>
@@ -22053,7 +21928,7 @@
               </a:rPr>
               <a:t>little training text</a:t>
             </a:r>
-            <a:endParaRPr lang="en-US" sz="1200" dirty="0"/>
+            <a:endParaRPr lang="en-US" sz="1150" dirty="0"/>
           </a:p>
         </p:txBody>
       </p:sp>
@@ -22065,7 +21940,7 @@
         </p:nvSpPr>
         <p:spPr>
           <a:xfrm>
-            <a:off x="960120" y="4636008"/>
+            <a:off x="777240" y="4636008"/>
             <a:ext cx="3840480" cy="685800"/>
           </a:xfrm>
           <a:prstGeom prst="rect">
@@ -22104,8 +21979,8 @@
         </p:nvSpPr>
         <p:spPr>
           <a:xfrm>
-            <a:off x="256032" y="2948940"/>
-            <a:ext cx="1371600" cy="685800"/>
+            <a:off x="228600" y="2948940"/>
+            <a:ext cx="1188720" cy="685800"/>
           </a:xfrm>
           <a:prstGeom prst="rect">
             <a:avLst/>
@@ -22121,7 +21996,7 @@
               <a:buNone/>
             </a:pPr>
             <a:r>
-              <a:rPr lang="en-US" sz="1200" dirty="0">
+              <a:rPr lang="en-US" sz="1150" dirty="0">
                 <a:solidFill>
                   <a:srgbClr val="1A1A1A"/>
                 </a:solidFill>
@@ -22131,7 +22006,7 @@
               </a:rPr>
               <a:t>fewer people write</a:t>
             </a:r>
-            <a:endParaRPr lang="en-US" sz="1200" dirty="0"/>
+            <a:endParaRPr lang="en-US" sz="1150" dirty="0"/>
           </a:p>
         </p:txBody>
       </p:sp>
@@ -22143,7 +22018,7 @@
         </p:nvSpPr>
         <p:spPr>
           <a:xfrm>
-            <a:off x="7754112" y="1243584"/>
+            <a:off x="7936992" y="1243584"/>
             <a:ext cx="3108960" cy="685800"/>
           </a:xfrm>
           <a:prstGeom prst="rect">
@@ -22182,8 +22057,8 @@
         </p:nvSpPr>
         <p:spPr>
           <a:xfrm>
-            <a:off x="10661904" y="2948940"/>
-            <a:ext cx="1417320" cy="685800"/>
+            <a:off x="10835640" y="2948940"/>
+            <a:ext cx="1280160" cy="685800"/>
           </a:xfrm>
           <a:prstGeom prst="rect">
             <a:avLst/>
@@ -22199,7 +22074,7 @@
               <a:buNone/>
             </a:pPr>
             <a:r>
-              <a:rPr lang="en-US" sz="1200" dirty="0">
+              <a:rPr lang="en-US" sz="1150" dirty="0">
                 <a:solidFill>
                   <a:srgbClr val="1A1A1A"/>
                 </a:solidFill>
@@ -22209,7 +22084,7 @@
               </a:rPr>
               <a:t>digital footprint</a:t>
             </a:r>
-            <a:endParaRPr lang="en-US" sz="1200" dirty="0"/>
+            <a:endParaRPr lang="en-US" sz="1150" dirty="0"/>
           </a:p>
         </p:txBody>
       </p:sp>
@@ -22221,7 +22096,7 @@
         </p:nvSpPr>
         <p:spPr>
           <a:xfrm>
-            <a:off x="7388352" y="4636008"/>
+            <a:off x="7571232" y="4636008"/>
             <a:ext cx="3840480" cy="685800"/>
           </a:xfrm>
           <a:prstGeom prst="rect">
@@ -22260,8 +22135,8 @@
         </p:nvSpPr>
         <p:spPr>
           <a:xfrm>
-            <a:off x="6583680" y="2948940"/>
-            <a:ext cx="1371600" cy="685800"/>
+            <a:off x="6912864" y="2948940"/>
+            <a:ext cx="1234440" cy="685800"/>
           </a:xfrm>
           <a:prstGeom prst="rect">
             <a:avLst/>
@@ -22277,7 +22152,7 @@
               <a:buNone/>
             </a:pPr>
             <a:r>
-              <a:rPr lang="en-US" sz="1200" dirty="0">
+              <a:rPr lang="en-US" sz="1150" dirty="0">
                 <a:solidFill>
                   <a:srgbClr val="1A1A1A"/>
                 </a:solidFill>
@@ -22287,7 +22162,7 @@
               </a:rPr>
               <a:t>faster articles</a:t>
             </a:r>
-            <a:endParaRPr lang="en-US" sz="1200" dirty="0"/>
+            <a:endParaRPr lang="en-US" sz="1150" dirty="0"/>
           </a:p>
         </p:txBody>
       </p:sp>
@@ -22299,8 +22174,8 @@
         </p:nvSpPr>
         <p:spPr>
           <a:xfrm>
-            <a:off x="5294376" y="2944368"/>
-            <a:ext cx="1609344" cy="713232"/>
+            <a:off x="5385816" y="2944368"/>
+            <a:ext cx="1417320" cy="713232"/>
           </a:xfrm>
           <a:prstGeom prst="roundRect">
             <a:avLst>
@@ -22326,8 +22201,8 @@
         </p:nvSpPr>
         <p:spPr>
           <a:xfrm>
-            <a:off x="5294376" y="2944368"/>
-            <a:ext cx="1609344" cy="713232"/>
+            <a:off x="5385816" y="2944368"/>
+            <a:ext cx="1417320" cy="713232"/>
           </a:xfrm>
           <a:prstGeom prst="rect">
             <a:avLst/>
@@ -22343,7 +22218,7 @@
               <a:buNone/>
             </a:pPr>
             <a:r>
-              <a:rPr lang="en-US" sz="1500" b="1" spc="100" kern="0" dirty="0">
+              <a:rPr lang="en-US" sz="1350" b="1" spc="50" kern="0" dirty="0">
                 <a:solidFill>
                   <a:srgbClr val="D9A441"/>
                 </a:solidFill>
@@ -22353,7 +22228,7 @@
               </a:rPr>
               <a:t>VERIFICATION</a:t>
             </a:r>
-            <a:endParaRPr lang="en-US" sz="1500" dirty="0"/>
+            <a:endParaRPr lang="en-US" sz="1350" dirty="0"/>
           </a:p>
         </p:txBody>
       </p:sp>
@@ -22475,8 +22350,8 @@
         </p:nvSpPr>
         <p:spPr>
           <a:xfrm>
-            <a:off x="685800" y="685800"/>
-            <a:ext cx="3392424" cy="4937760"/>
+            <a:off x="685800" y="777240"/>
+            <a:ext cx="3392424" cy="4846320"/>
           </a:xfrm>
           <a:prstGeom prst="roundRect">
             <a:avLst>
@@ -22509,8 +22384,8 @@
         </p:nvSpPr>
         <p:spPr>
           <a:xfrm>
-            <a:off x="4398264" y="685800"/>
-            <a:ext cx="3392424" cy="4937760"/>
+            <a:off x="4398264" y="777240"/>
+            <a:ext cx="3392424" cy="4846320"/>
           </a:xfrm>
           <a:prstGeom prst="roundRect">
             <a:avLst>
@@ -22543,8 +22418,8 @@
         </p:nvSpPr>
         <p:spPr>
           <a:xfrm>
-            <a:off x="8110728" y="685800"/>
-            <a:ext cx="3392424" cy="4937760"/>
+            <a:off x="8110728" y="777240"/>
+            <a:ext cx="3392424" cy="4846320"/>
           </a:xfrm>
           <a:prstGeom prst="roundRect">
             <a:avLst>
@@ -22577,7 +22452,7 @@
         </p:nvSpPr>
         <p:spPr>
           <a:xfrm>
-            <a:off x="1879092" y="1069848"/>
+            <a:off x="1879092" y="1097280"/>
             <a:ext cx="1005840" cy="1005840"/>
           </a:xfrm>
           <a:prstGeom prst="ellipse">
@@ -22602,7 +22477,7 @@
         </p:nvSpPr>
         <p:spPr>
           <a:xfrm>
-            <a:off x="1879092" y="1069848"/>
+            <a:off x="1879092" y="1097280"/>
             <a:ext cx="1005840" cy="1005840"/>
           </a:xfrm>
           <a:prstGeom prst="rect">
@@ -22638,7 +22513,7 @@
         </p:nvSpPr>
         <p:spPr>
           <a:xfrm>
-            <a:off x="5591556" y="1069848"/>
+            <a:off x="5591556" y="1097280"/>
             <a:ext cx="1005840" cy="1005840"/>
           </a:xfrm>
           <a:prstGeom prst="ellipse">
@@ -22663,7 +22538,7 @@
         </p:nvSpPr>
         <p:spPr>
           <a:xfrm>
-            <a:off x="5591556" y="1069848"/>
+            <a:off x="5591556" y="1097280"/>
             <a:ext cx="1005840" cy="1005840"/>
           </a:xfrm>
           <a:prstGeom prst="rect">
@@ -22699,7 +22574,7 @@
         </p:nvSpPr>
         <p:spPr>
           <a:xfrm>
-            <a:off x="9304020" y="1069848"/>
+            <a:off x="9304020" y="1097280"/>
             <a:ext cx="1005840" cy="1005840"/>
           </a:xfrm>
           <a:prstGeom prst="ellipse">
@@ -22724,7 +22599,7 @@
         </p:nvSpPr>
         <p:spPr>
           <a:xfrm>
-            <a:off x="9304020" y="1069848"/>
+            <a:off x="9304020" y="1097280"/>
             <a:ext cx="1005840" cy="1005840"/>
           </a:xfrm>
           <a:prstGeom prst="rect">
@@ -22799,8 +22674,8 @@
         </p:nvSpPr>
         <p:spPr>
           <a:xfrm>
-            <a:off x="685800" y="2807208"/>
-            <a:ext cx="3392424" cy="411480"/>
+            <a:off x="4398264" y="2286000"/>
+            <a:ext cx="3392424" cy="457200"/>
           </a:xfrm>
           <a:prstGeom prst="rect">
             <a:avLst/>
@@ -22816,7 +22691,85 @@
               <a:buNone/>
             </a:pPr>
             <a:r>
-              <a:rPr lang="en-US" sz="1500" dirty="0">
+              <a:rPr lang="en-US" sz="2500" b="1" dirty="0">
+                <a:solidFill>
+                  <a:srgbClr val="1A1A1A"/>
+                </a:solidFill>
+                <a:latin typeface="Archivo" pitchFamily="34" charset="0"/>
+                <a:ea typeface="Archivo" pitchFamily="34" charset="-122"/>
+                <a:cs typeface="Archivo" pitchFamily="34" charset="-120"/>
+              </a:rPr>
+              <a:t>Unsupervised</a:t>
+            </a:r>
+            <a:endParaRPr lang="en-US" sz="2500" dirty="0"/>
+          </a:p>
+        </p:txBody>
+      </p:sp>
+      <p:sp>
+        <p:nvSpPr>
+          <p:cNvPr id="13" name="Text 11"/>
+          <p:cNvSpPr/>
+          <p:nvPr/>
+        </p:nvSpPr>
+        <p:spPr>
+          <a:xfrm>
+            <a:off x="8110728" y="2286000"/>
+            <a:ext cx="3392424" cy="457200"/>
+          </a:xfrm>
+          <a:prstGeom prst="rect">
+            <a:avLst/>
+          </a:prstGeom>
+          <a:noFill/>
+          <a:ln/>
+        </p:spPr>
+        <p:txBody>
+          <a:bodyPr wrap="square" rtlCol="0" anchor="ctr"/>
+          <a:lstStyle/>
+          <a:p>
+            <a:pPr algn="ctr" indent="0" marL="0">
+              <a:buNone/>
+            </a:pPr>
+            <a:r>
+              <a:rPr lang="en-US" sz="2500" b="1" dirty="0">
+                <a:solidFill>
+                  <a:srgbClr val="1A1A1A"/>
+                </a:solidFill>
+                <a:latin typeface="Archivo" pitchFamily="34" charset="0"/>
+                <a:ea typeface="Archivo" pitchFamily="34" charset="-122"/>
+                <a:cs typeface="Archivo" pitchFamily="34" charset="-120"/>
+              </a:rPr>
+              <a:t>Supervised</a:t>
+            </a:r>
+            <a:endParaRPr lang="en-US" sz="2500" dirty="0"/>
+          </a:p>
+        </p:txBody>
+      </p:sp>
+      <p:sp>
+        <p:nvSpPr>
+          <p:cNvPr id="14" name="Text 12"/>
+          <p:cNvSpPr/>
+          <p:nvPr/>
+        </p:nvSpPr>
+        <p:spPr>
+          <a:xfrm>
+            <a:off x="4626864" y="2807208"/>
+            <a:ext cx="2935224" cy="594360"/>
+          </a:xfrm>
+          <a:prstGeom prst="rect">
+            <a:avLst/>
+          </a:prstGeom>
+          <a:noFill/>
+          <a:ln/>
+        </p:spPr>
+        <p:txBody>
+          <a:bodyPr wrap="square" rtlCol="0" anchor="ctr"/>
+          <a:lstStyle/>
+          <a:p>
+            <a:pPr algn="ctr" indent="0" marL="0">
+              <a:buNone/>
+            </a:pPr>
+            <a:r>
+              <a:rPr lang="en-US" sz="1350" dirty="0">
                 <a:solidFill>
                   <a:srgbClr val="8A8378"/>
                 </a:solidFill>
@@ -22824,77 +22777,65 @@
                 <a:ea typeface="Inter" pitchFamily="34" charset="-122"/>
                 <a:cs typeface="Inter" pitchFamily="34" charset="-120"/>
               </a:rPr>
-              <a:t>too slow</a:t>
-            </a:r>
-            <a:endParaRPr lang="en-US" sz="1500" dirty="0"/>
-          </a:p>
-        </p:txBody>
-      </p:sp>
-      <p:sp>
-        <p:nvSpPr>
-          <p:cNvPr id="13" name="Text 11"/>
-          <p:cNvSpPr/>
-          <p:nvPr/>
-        </p:nvSpPr>
-        <p:spPr>
-          <a:xfrm>
-            <a:off x="4398264" y="2286000"/>
-            <a:ext cx="3392424" cy="457200"/>
-          </a:xfrm>
-          <a:prstGeom prst="rect">
-            <a:avLst/>
-          </a:prstGeom>
-          <a:noFill/>
-          <a:ln/>
-        </p:spPr>
-        <p:txBody>
-          <a:bodyPr wrap="square" rtlCol="0" anchor="ctr"/>
+              <a:t>Scots · Cebuano · Greenlandic (closed, 2025)</a:t>
+            </a:r>
+            <a:endParaRPr lang="en-US" sz="1350" dirty="0"/>
+          </a:p>
+        </p:txBody>
+      </p:sp>
+      <p:sp>
+        <p:nvSpPr>
+          <p:cNvPr id="15" name="Shape 13"/>
+          <p:cNvSpPr/>
+          <p:nvPr/>
+        </p:nvSpPr>
+        <p:spPr>
+          <a:xfrm>
+            <a:off x="960120" y="3474720"/>
+            <a:ext cx="2843784" cy="1783080"/>
+          </a:xfrm>
+          <a:prstGeom prst="roundRect">
+            <a:avLst>
+              <a:gd name="adj" fmla="val 4615"/>
+            </a:avLst>
+          </a:prstGeom>
+          <a:solidFill>
+            <a:srgbClr val="F3EDE4"/>
+          </a:solidFill>
+          <a:ln w="9525">
+            <a:solidFill>
+              <a:srgbClr val="B8B2A8"/>
+            </a:solidFill>
+            <a:prstDash val="solid"/>
+          </a:ln>
+        </p:spPr>
+      </p:sp>
+      <p:sp>
+        <p:nvSpPr>
+          <p:cNvPr id="16" name="Text 14"/>
+          <p:cNvSpPr/>
+          <p:nvPr/>
+        </p:nvSpPr>
+        <p:spPr>
+          <a:xfrm>
+            <a:off x="960120" y="3474720"/>
+            <a:ext cx="2843784" cy="1783080"/>
+          </a:xfrm>
+          <a:prstGeom prst="rect">
+            <a:avLst/>
+          </a:prstGeom>
+          <a:noFill/>
+          <a:ln/>
+        </p:spPr>
+        <p:txBody>
+          <a:bodyPr wrap="square" lIns="0" tIns="0" rIns="0" bIns="0" rtlCol="0" anchor="ctr"/>
           <a:lstStyle/>
           <a:p>
             <a:pPr algn="ctr" indent="0" marL="0">
               <a:buNone/>
             </a:pPr>
             <a:r>
-              <a:rPr lang="en-US" sz="2500" b="1" dirty="0">
-                <a:solidFill>
-                  <a:srgbClr val="1A1A1A"/>
-                </a:solidFill>
-                <a:latin typeface="Archivo" pitchFamily="34" charset="0"/>
-                <a:ea typeface="Archivo" pitchFamily="34" charset="-122"/>
-                <a:cs typeface="Archivo" pitchFamily="34" charset="-120"/>
-              </a:rPr>
-              <a:t>Unsupervised</a:t>
-            </a:r>
-            <a:endParaRPr lang="en-US" sz="2500" dirty="0"/>
-          </a:p>
-        </p:txBody>
-      </p:sp>
-      <p:sp>
-        <p:nvSpPr>
-          <p:cNvPr id="14" name="Text 12"/>
-          <p:cNvSpPr/>
-          <p:nvPr/>
-        </p:nvSpPr>
-        <p:spPr>
-          <a:xfrm>
-            <a:off x="4626864" y="2770632"/>
-            <a:ext cx="2935224" cy="594360"/>
-          </a:xfrm>
-          <a:prstGeom prst="rect">
-            <a:avLst/>
-          </a:prstGeom>
-          <a:noFill/>
-          <a:ln/>
-        </p:spPr>
-        <p:txBody>
-          <a:bodyPr wrap="square" rtlCol="0" anchor="ctr"/>
-          <a:lstStyle/>
-          <a:p>
-            <a:pPr algn="ctr" indent="0" marL="0">
-              <a:buNone/>
-            </a:pPr>
-            <a:r>
-              <a:rPr lang="en-US" sz="1350" dirty="0">
+              <a:rPr lang="en-US" sz="1800" dirty="0">
                 <a:solidFill>
                   <a:srgbClr val="8A8378"/>
                 </a:solidFill>
@@ -22902,26 +22843,26 @@
                 <a:ea typeface="Inter" pitchFamily="34" charset="-122"/>
                 <a:cs typeface="Inter" pitchFamily="34" charset="-120"/>
               </a:rPr>
-              <a:t>Scots · Cebuano · Greenlandic (closed, 2025)</a:t>
-            </a:r>
-            <a:endParaRPr lang="en-US" sz="1350" dirty="0"/>
-          </a:p>
-        </p:txBody>
-      </p:sp>
-      <p:sp>
-        <p:nvSpPr>
-          <p:cNvPr id="15" name="Shape 13"/>
+              <a:t>too slow</a:t>
+            </a:r>
+            <a:endParaRPr lang="en-US" sz="1800" dirty="0"/>
+          </a:p>
+        </p:txBody>
+      </p:sp>
+      <p:sp>
+        <p:nvSpPr>
+          <p:cNvPr id="17" name="Shape 15"/>
           <p:cNvSpPr/>
           <p:nvPr/>
         </p:nvSpPr>
         <p:spPr>
           <a:xfrm>
             <a:off x="4672584" y="3474720"/>
-            <a:ext cx="2843784" cy="1828800"/>
+            <a:ext cx="2843784" cy="1783080"/>
           </a:xfrm>
           <a:prstGeom prst="roundRect">
             <a:avLst>
-              <a:gd name="adj" fmla="val 4500"/>
+              <a:gd name="adj" fmla="val 4615"/>
             </a:avLst>
           </a:prstGeom>
           <a:solidFill>
@@ -22937,14 +22878,14 @@
       </p:sp>
       <p:sp>
         <p:nvSpPr>
-          <p:cNvPr id="16" name="Text 14"/>
+          <p:cNvPr id="18" name="Text 16"/>
           <p:cNvSpPr/>
           <p:nvPr/>
         </p:nvSpPr>
         <p:spPr>
           <a:xfrm>
             <a:off x="4672584" y="3474720"/>
-            <a:ext cx="2843784" cy="1828800"/>
+            <a:ext cx="2843784" cy="1783080"/>
           </a:xfrm>
           <a:prstGeom prst="rect">
             <a:avLst/>
@@ -22993,69 +22934,57 @@
       </p:sp>
       <p:sp>
         <p:nvSpPr>
-          <p:cNvPr id="17" name="Text 15"/>
-          <p:cNvSpPr/>
-          <p:nvPr/>
-        </p:nvSpPr>
-        <p:spPr>
-          <a:xfrm>
-            <a:off x="8110728" y="2286000"/>
-            <a:ext cx="3392424" cy="457200"/>
-          </a:xfrm>
-          <a:prstGeom prst="rect">
-            <a:avLst/>
-          </a:prstGeom>
-          <a:noFill/>
-          <a:ln/>
-        </p:spPr>
-        <p:txBody>
-          <a:bodyPr wrap="square" rtlCol="0" anchor="ctr"/>
+          <p:cNvPr id="19" name="Shape 17"/>
+          <p:cNvSpPr/>
+          <p:nvPr/>
+        </p:nvSpPr>
+        <p:spPr>
+          <a:xfrm>
+            <a:off x="8385048" y="3474720"/>
+            <a:ext cx="2843784" cy="1783080"/>
+          </a:xfrm>
+          <a:prstGeom prst="roundRect">
+            <a:avLst>
+              <a:gd name="adj" fmla="val 4615"/>
+            </a:avLst>
+          </a:prstGeom>
+          <a:solidFill>
+            <a:srgbClr val="FFFFFF"/>
+          </a:solidFill>
+          <a:ln w="12700">
+            <a:solidFill>
+              <a:srgbClr val="B03A1E"/>
+            </a:solidFill>
+            <a:prstDash val="solid"/>
+          </a:ln>
+        </p:spPr>
+      </p:sp>
+      <p:sp>
+        <p:nvSpPr>
+          <p:cNvPr id="20" name="Text 18"/>
+          <p:cNvSpPr/>
+          <p:nvPr/>
+        </p:nvSpPr>
+        <p:spPr>
+          <a:xfrm>
+            <a:off x="8385048" y="3474720"/>
+            <a:ext cx="2843784" cy="1783080"/>
+          </a:xfrm>
+          <a:prstGeom prst="rect">
+            <a:avLst/>
+          </a:prstGeom>
+          <a:noFill/>
+          <a:ln/>
+        </p:spPr>
+        <p:txBody>
+          <a:bodyPr wrap="square" lIns="0" tIns="0" rIns="0" bIns="0" rtlCol="0" anchor="ctr"/>
           <a:lstStyle/>
           <a:p>
             <a:pPr algn="ctr" indent="0" marL="0">
               <a:buNone/>
             </a:pPr>
             <a:r>
-              <a:rPr lang="en-US" sz="2500" b="1" dirty="0">
-                <a:solidFill>
-                  <a:srgbClr val="1A1A1A"/>
-                </a:solidFill>
-                <a:latin typeface="Archivo" pitchFamily="34" charset="0"/>
-                <a:ea typeface="Archivo" pitchFamily="34" charset="-122"/>
-                <a:cs typeface="Archivo" pitchFamily="34" charset="-120"/>
-              </a:rPr>
-              <a:t>Supervised</a:t>
-            </a:r>
-            <a:endParaRPr lang="en-US" sz="2500" dirty="0"/>
-          </a:p>
-        </p:txBody>
-      </p:sp>
-      <p:sp>
-        <p:nvSpPr>
-          <p:cNvPr id="18" name="Text 16"/>
-          <p:cNvSpPr/>
-          <p:nvPr/>
-        </p:nvSpPr>
-        <p:spPr>
-          <a:xfrm>
-            <a:off x="8110728" y="2807208"/>
-            <a:ext cx="3392424" cy="411480"/>
-          </a:xfrm>
-          <a:prstGeom prst="rect">
-            <a:avLst/>
-          </a:prstGeom>
-          <a:noFill/>
-          <a:ln/>
-        </p:spPr>
-        <p:txBody>
-          <a:bodyPr wrap="square" rtlCol="0" anchor="ctr"/>
-          <a:lstStyle/>
-          <a:p>
-            <a:pPr algn="ctr" indent="0" marL="0">
-              <a:buNone/>
-            </a:pPr>
-            <a:r>
-              <a:rPr lang="en-US" sz="1600" b="1" dirty="0">
+              <a:rPr lang="en-US" sz="1900" b="1" dirty="0">
                 <a:solidFill>
                   <a:srgbClr val="B03A1E"/>
                 </a:solidFill>
@@ -23065,19 +22994,19 @@
               </a:rPr>
               <a:t>this talk</a:t>
             </a:r>
-            <a:endParaRPr lang="en-US" sz="1600" dirty="0"/>
-          </a:p>
-        </p:txBody>
-      </p:sp>
-      <p:sp>
-        <p:nvSpPr>
-          <p:cNvPr id="19" name="Text 17"/>
-          <p:cNvSpPr/>
-          <p:nvPr/>
-        </p:nvSpPr>
-        <p:spPr>
-          <a:xfrm>
-            <a:off x="685800" y="5989320"/>
+            <a:endParaRPr lang="en-US" sz="1900" dirty="0"/>
+          </a:p>
+        </p:txBody>
+      </p:sp>
+      <p:sp>
+        <p:nvSpPr>
+          <p:cNvPr id="21" name="Text 19"/>
+          <p:cNvSpPr/>
+          <p:nvPr/>
+        </p:nvSpPr>
+        <p:spPr>
+          <a:xfrm>
+            <a:off x="685800" y="5943600"/>
             <a:ext cx="10817352" cy="502920"/>
           </a:xfrm>
           <a:prstGeom prst="rect">
@@ -23110,7 +23039,7 @@
       </p:sp>
       <p:sp>
         <p:nvSpPr>
-          <p:cNvPr id="20" name="Text 18"/>
+          <p:cNvPr id="22" name="Text 20"/>
           <p:cNvSpPr/>
           <p:nvPr/>
         </p:nvSpPr>
@@ -23187,7 +23116,7 @@
         </p:nvSpPr>
         <p:spPr>
           <a:xfrm>
-            <a:off x="685800" y="594360"/>
+            <a:off x="685800" y="640080"/>
             <a:ext cx="10789920" cy="731520"/>
           </a:xfrm>
           <a:prstGeom prst="rect">
@@ -23226,12 +23155,12 @@
         </p:nvSpPr>
         <p:spPr>
           <a:xfrm>
-            <a:off x="822960" y="2286000"/>
-            <a:ext cx="12252960" cy="713232"/>
+            <a:off x="822960" y="2148840"/>
+            <a:ext cx="12252960" cy="777240"/>
           </a:xfrm>
           <a:prstGeom prst="roundRect">
             <a:avLst>
-              <a:gd name="adj" fmla="val 10256"/>
+              <a:gd name="adj" fmla="val 9412"/>
             </a:avLst>
           </a:prstGeom>
           <a:solidFill>
@@ -23248,8 +23177,8 @@
         </p:nvSpPr>
         <p:spPr>
           <a:xfrm>
-            <a:off x="1097280" y="2340864"/>
-            <a:ext cx="3200400" cy="603504"/>
+            <a:off x="1143000" y="2212848"/>
+            <a:ext cx="3200400" cy="649224"/>
           </a:xfrm>
           <a:prstGeom prst="rect">
             <a:avLst/>
@@ -23265,7 +23194,7 @@
               <a:buNone/>
             </a:pPr>
             <a:r>
-              <a:rPr lang="en-US" sz="2600" b="1" dirty="0">
+              <a:rPr lang="en-US" sz="2700" b="1" dirty="0">
                 <a:solidFill>
                   <a:srgbClr val="1A1A1A"/>
                 </a:solidFill>
@@ -23275,7 +23204,7 @@
               </a:rPr>
               <a:t>~285 years</a:t>
             </a:r>
-            <a:endParaRPr lang="en-US" sz="2600" dirty="0"/>
+            <a:endParaRPr lang="en-US" sz="2700" dirty="0"/>
           </a:p>
         </p:txBody>
       </p:sp>
@@ -23287,12 +23216,12 @@
         </p:nvSpPr>
         <p:spPr>
           <a:xfrm>
-            <a:off x="822960" y="3611880"/>
-            <a:ext cx="1965960" cy="713232"/>
+            <a:off x="822960" y="3657600"/>
+            <a:ext cx="1965960" cy="777240"/>
           </a:xfrm>
           <a:prstGeom prst="roundRect">
             <a:avLst>
-              <a:gd name="adj" fmla="val 10256"/>
+              <a:gd name="adj" fmla="val 9412"/>
             </a:avLst>
           </a:prstGeom>
           <a:solidFill>
@@ -23309,8 +23238,8 @@
         </p:nvSpPr>
         <p:spPr>
           <a:xfrm>
-            <a:off x="3017520" y="3666744"/>
-            <a:ext cx="8138160" cy="603504"/>
+            <a:off x="3063240" y="3721608"/>
+            <a:ext cx="8138160" cy="649224"/>
           </a:xfrm>
           <a:prstGeom prst="rect">
             <a:avLst/>
@@ -23348,12 +23277,12 @@
         </p:nvSpPr>
         <p:spPr>
           <a:xfrm>
-            <a:off x="822960" y="4983480"/>
-            <a:ext cx="6766560" cy="868680"/>
+            <a:off x="822960" y="5166360"/>
+            <a:ext cx="7863840" cy="914400"/>
           </a:xfrm>
           <a:prstGeom prst="roundRect">
             <a:avLst>
-              <a:gd name="adj" fmla="val 10526"/>
+              <a:gd name="adj" fmla="val 10000"/>
             </a:avLst>
           </a:prstGeom>
           <a:solidFill>
@@ -23382,8 +23311,8 @@
         </p:nvSpPr>
         <p:spPr>
           <a:xfrm>
-            <a:off x="1097280" y="4983480"/>
-            <a:ext cx="6309360" cy="868680"/>
+            <a:off x="1143000" y="5166360"/>
+            <a:ext cx="7406640" cy="914400"/>
           </a:xfrm>
           <a:prstGeom prst="rect">
             <a:avLst/>

</xml_diff>